<commit_message>
deck: fill team details (Team Zen — Hiran Vikraman S R, Arun G K) + stronger marketing (impact, real-world use cases); add video recording tooling
</commit_message>
<xml_diff>
--- a/ANVESHAK_KSP_Datathon_2026_Submission.pptx
+++ b/ANVESHAK_KSP_Datathon_2026_Submission.pptx
@@ -7049,11 +7049,11 @@
             <a:r>
               <a:rPr sz="1400" b="0">
                 <a:solidFill>
-                  <a:srgbClr val="8A97A8"/>
-                </a:solidFill>
-                <a:latin typeface="Calibri"/>
-              </a:rPr>
-              <a:t>Team leader name:  (add before submitting)</a:t>
+                  <a:srgbClr val="CFD8E6"/>
+                </a:solidFill>
+                <a:latin typeface="Calibri"/>
+              </a:rPr>
+              <a:t>Team leader name:  Hiran Vikraman S R</a:t>
             </a:r>
           </a:p>
           <a:p>
@@ -7065,11 +7065,11 @@
             <a:r>
               <a:rPr sz="1400" b="0">
                 <a:solidFill>
-                  <a:srgbClr val="8A97A8"/>
-                </a:solidFill>
-                <a:latin typeface="Calibri"/>
-              </a:rPr>
-              <a:t>Team size:  (add before submitting)</a:t>
+                  <a:srgbClr val="CFD8E6"/>
+                </a:solidFill>
+                <a:latin typeface="Calibri"/>
+              </a:rPr>
+              <a:t>Team size:  2   (Hiran Vikraman S R · Arun G K)</a:t>
             </a:r>
           </a:p>
           <a:p>
@@ -8634,7 +8634,25 @@
                 </a:solidFill>
                 <a:latin typeface="Calibri"/>
               </a:rPr>
-              <a:t> = “the investigator”) is an autonomous AI investigation bureau over the KSP crime database — not just a chatbot.</a:t>
+              <a:t> = “the investigator”) turns the KSP crime database into an </a:t>
+            </a:r>
+            <a:r>
+              <a:rPr sz="1300" b="1">
+                <a:solidFill>
+                  <a:srgbClr val="FFFFFF"/>
+                </a:solidFill>
+                <a:latin typeface="Calibri"/>
+              </a:rPr>
+              <a:t>AI investigation partner</a:t>
+            </a:r>
+            <a:r>
+              <a:rPr sz="1300" b="0">
+                <a:solidFill>
+                  <a:srgbClr val="CFD8E6"/>
+                </a:solidFill>
+                <a:latin typeface="Calibri"/>
+              </a:rPr>
+              <a:t> — not just a chatbot.</a:t>
             </a:r>
           </a:p>
           <a:p>
@@ -8650,7 +8668,25 @@
                 </a:solidFill>
                 <a:latin typeface="Calibri"/>
               </a:rPr>
-              <a:t>• Officers ask in Kannada or English, by voice or text. Every answer is grounded in verified SQL with a visible evidence drawer (SQL + rows + case IDs).</a:t>
+              <a:t>• Ask in Kannada or English, by voice or text — get an answer in seconds, </a:t>
+            </a:r>
+            <a:r>
+              <a:rPr sz="1200" b="1">
+                <a:solidFill>
+                  <a:srgbClr val="FFFFFF"/>
+                </a:solidFill>
+                <a:latin typeface="Calibri"/>
+              </a:rPr>
+              <a:t>with the evidence</a:t>
+            </a:r>
+            <a:r>
+              <a:rPr sz="1200" b="0">
+                <a:solidFill>
+                  <a:srgbClr val="CFD8E6"/>
+                </a:solidFill>
+                <a:latin typeface="Calibri"/>
+              </a:rPr>
+              <a:t> (SQL + rows + case IDs) attached. No SQL skills, no analyst queue.</a:t>
             </a:r>
           </a:p>
           <a:p>
@@ -8675,7 +8711,7 @@
                 </a:solidFill>
                 <a:latin typeface="Calibri"/>
               </a:rPr>
-              <a:t> — so every number traces to a tool result. No hallucinated statistics.</a:t>
+              <a:t> — every number traces to a tool result. Zero hallucinated statistics — essential for policing.</a:t>
             </a:r>
           </a:p>
           <a:p>
@@ -8691,7 +8727,7 @@
                 </a:solidFill>
                 <a:latin typeface="Calibri"/>
               </a:rPr>
-              <a:t>• Beyond Q&amp;A it works cases: cross-district serial-crime linkage, a 6-agent investigation cell that assembles court-ready packs, a crime knowledge graph, and an autonomous Night Patrol that raises leads before anyone asks.</a:t>
+              <a:t>• It doesn’t stop at answers — it works cases: links serial crime across districts, runs a 6-agent cell that assembles court-ready packs, traverses a crime knowledge graph, and sweeps overnight to raise leads before anyone asks.</a:t>
             </a:r>
           </a:p>
           <a:p>
@@ -8703,20 +8739,20 @@
             <a:r>
               <a:rPr sz="1200" b="1">
                 <a:solidFill>
+                  <a:srgbClr val="FFFFFF"/>
+                </a:solidFill>
+                <a:latin typeface="Calibri"/>
+              </a:rPr>
+              <a:t>• Impact: minutes instead of days, catches siloed records miss, and proactive leads every morning. </a:t>
+            </a:r>
+            <a:r>
+              <a:rPr sz="1200" b="1">
+                <a:solidFill>
                   <a:srgbClr val="5AD69C"/>
                 </a:solidFill>
                 <a:latin typeface="Calibri"/>
               </a:rPr>
-              <a:t>• Runs 100% on Zoho Catalyst.</a:t>
-            </a:r>
-            <a:r>
-              <a:rPr sz="1200" b="0">
-                <a:solidFill>
-                  <a:srgbClr val="5AB0FF"/>
-                </a:solidFill>
-                <a:latin typeface="Calibri"/>
-              </a:rPr>
-              <a:t>  Live: https://anveshak-api-50044329134.development.catalystappsail.in/ui/</a:t>
+              <a:t>Runs 100% on Zoho Catalyst.</a:t>
             </a:r>
           </a:p>
         </p:txBody>
@@ -9070,11 +9106,36 @@
           <a:p>
             <a:pPr>
               <a:spcAft>
+                <a:spcPts val="600"/>
+              </a:spcAft>
+            </a:pPr>
+            <a:r>
+              <a:rPr sz="1100" b="1">
+                <a:solidFill>
+                  <a:srgbClr val="FFFFFF"/>
+                </a:solidFill>
+                <a:latin typeface="Calibri"/>
+              </a:rPr>
+              <a:t>Where it makes a difference: </a:t>
+            </a:r>
+            <a:r>
+              <a:rPr sz="1100" b="0">
+                <a:solidFill>
+                  <a:srgbClr val="CFD8E6"/>
+                </a:solidFill>
+                <a:latin typeface="Calibri"/>
+              </a:rPr>
+              <a:t>a constable at a rural station gets a statewide answer in Kannada in seconds · an SP spots a serial ring crossing Mandya into Bengaluru before the next strike · an IO gets a first-draft, court-ready pack in minutes · a control room sees tomorrow’s hotspot tonight.</a:t>
+            </a:r>
+          </a:p>
+          <a:p>
+            <a:pPr>
+              <a:spcAft>
                 <a:spcPts val="200"/>
               </a:spcAft>
             </a:pPr>
             <a:r>
-              <a:rPr sz="1200" b="1">
+              <a:rPr sz="1150" b="1">
                 <a:solidFill>
                   <a:srgbClr val="5AB0FF"/>
                 </a:solidFill>
@@ -9083,7 +9144,7 @@
               <a:t>USP:  </a:t>
             </a:r>
             <a:r>
-              <a:rPr sz="1200" b="0">
+              <a:rPr sz="1150" b="0">
                 <a:solidFill>
                   <a:srgbClr val="FFFFFF"/>
                 </a:solidFill>

</xml_diff>

<commit_message>
deck: polish + PDF — remove blank slide, embed 6 live-app screenshots on Snapshots, dark palette for the template's white content area, fix multi-line prompt overlap (Links/Opportunities), team details. Export ANVESHAK_KSP_Datathon_2026_Submission.pdf
</commit_message>
<xml_diff>
--- a/ANVESHAK_KSP_Datathon_2026_Submission.pptx
+++ b/ANVESHAK_KSP_Datathon_2026_Submission.pptx
@@ -22,7 +22,6 @@
     <p:sldId id="267" r:id="rId17"/>
     <p:sldId id="268" r:id="rId18"/>
     <p:sldId id="269" r:id="rId19"/>
-    <p:sldId id="270" r:id="rId20"/>
     <p:sldId id="271" r:id="rId21"/>
   </p:sldIdLst>
   <p:sldSz cy="5143500" cx="9144000"/>
@@ -7000,7 +6999,7 @@
             <a:r>
               <a:rPr sz="1700" b="1">
                 <a:solidFill>
-                  <a:srgbClr val="FFFFFF"/>
+                  <a:srgbClr val="0B1F3A"/>
                 </a:solidFill>
                 <a:latin typeface="Calibri"/>
               </a:rPr>
@@ -7017,7 +7016,7 @@
             <a:r>
               <a:rPr sz="600" b="0">
                 <a:solidFill>
-                  <a:srgbClr val="CFD8E6"/>
+                  <a:srgbClr val="2B374B"/>
                 </a:solidFill>
                 <a:latin typeface="Calibri"/>
               </a:rPr>
@@ -7033,7 +7032,7 @@
             <a:r>
               <a:rPr sz="1400" b="0">
                 <a:solidFill>
-                  <a:srgbClr val="CFD8E6"/>
+                  <a:srgbClr val="2B374B"/>
                 </a:solidFill>
                 <a:latin typeface="Calibri"/>
               </a:rPr>
@@ -7049,7 +7048,7 @@
             <a:r>
               <a:rPr sz="1400" b="0">
                 <a:solidFill>
-                  <a:srgbClr val="CFD8E6"/>
+                  <a:srgbClr val="2B374B"/>
                 </a:solidFill>
                 <a:latin typeface="Calibri"/>
               </a:rPr>
@@ -7065,7 +7064,7 @@
             <a:r>
               <a:rPr sz="1400" b="0">
                 <a:solidFill>
-                  <a:srgbClr val="CFD8E6"/>
+                  <a:srgbClr val="2B374B"/>
                 </a:solidFill>
                 <a:latin typeface="Calibri"/>
               </a:rPr>
@@ -7081,7 +7080,7 @@
             <a:r>
               <a:rPr sz="1300" b="0">
                 <a:solidFill>
-                  <a:srgbClr val="CFD8E6"/>
+                  <a:srgbClr val="2B374B"/>
                 </a:solidFill>
                 <a:latin typeface="Calibri"/>
               </a:rPr>
@@ -7215,7 +7214,7 @@
             <a:r>
               <a:rPr sz="1200" b="1">
                 <a:solidFill>
-                  <a:srgbClr val="FFFFFF"/>
+                  <a:srgbClr val="0B1F3A"/>
                 </a:solidFill>
                 <a:latin typeface="Calibri"/>
               </a:rPr>
@@ -7231,7 +7230,7 @@
             <a:r>
               <a:rPr sz="1200" b="0">
                 <a:solidFill>
-                  <a:srgbClr val="CFD8E6"/>
+                  <a:srgbClr val="2B374B"/>
                 </a:solidFill>
                 <a:latin typeface="Calibri"/>
               </a:rPr>
@@ -7247,7 +7246,7 @@
             <a:r>
               <a:rPr sz="1200" b="0">
                 <a:solidFill>
-                  <a:srgbClr val="CFD8E6"/>
+                  <a:srgbClr val="2B374B"/>
                 </a:solidFill>
                 <a:latin typeface="Calibri"/>
               </a:rPr>
@@ -7263,7 +7262,7 @@
             <a:r>
               <a:rPr sz="1200" b="0">
                 <a:solidFill>
-                  <a:srgbClr val="CFD8E6"/>
+                  <a:srgbClr val="2B374B"/>
                 </a:solidFill>
                 <a:latin typeface="Calibri"/>
               </a:rPr>
@@ -7279,7 +7278,7 @@
             <a:r>
               <a:rPr sz="1200" b="0">
                 <a:solidFill>
-                  <a:srgbClr val="CFD8E6"/>
+                  <a:srgbClr val="2B374B"/>
                 </a:solidFill>
                 <a:latin typeface="Calibri"/>
               </a:rPr>
@@ -7383,16 +7382,40 @@
           </a:p>
         </p:txBody>
       </p:sp>
+      <p:pic>
+        <p:nvPicPr>
+          <p:cNvPr id="115" name="Picture 114" descr="01_leadfeed.png"/>
+          <p:cNvPicPr>
+            <a:picLocks noChangeAspect="1"/>
+          </p:cNvPicPr>
+          <p:nvPr/>
+        </p:nvPicPr>
+        <p:blipFill>
+          <a:blip r:embed="rId4"/>
+          <a:stretch>
+            <a:fillRect/>
+          </a:stretch>
+        </p:blipFill>
+        <p:spPr>
+          <a:xfrm>
+            <a:off x="320040" y="1353312"/>
+            <a:ext cx="2724912" cy="1532763"/>
+          </a:xfrm>
+          <a:prstGeom prst="rect">
+            <a:avLst/>
+          </a:prstGeom>
+        </p:spPr>
+      </p:pic>
       <p:sp>
         <p:nvSpPr>
-          <p:cNvPr id="115" name="TextBox 114"/>
+          <p:cNvPr id="116" name="TextBox 115"/>
           <p:cNvSpPr txBox="1"/>
           <p:nvPr/>
         </p:nvSpPr>
         <p:spPr>
           <a:xfrm>
-            <a:off x="502920" y="1417320"/>
-            <a:ext cx="8183879" cy="3429000"/>
+            <a:off x="320040" y="2895219"/>
+            <a:ext cx="2724912" cy="237744"/>
           </a:xfrm>
           <a:prstGeom prst="rect">
             <a:avLst/>
@@ -7400,136 +7423,315 @@
           <a:noFill/>
         </p:spPr>
         <p:txBody>
-          <a:bodyPr wrap="square">
+          <a:bodyPr wrap="none">
             <a:spAutoFit/>
           </a:bodyPr>
           <a:lstStyle/>
           <a:p>
-            <a:pPr>
-              <a:spcAft>
-                <a:spcPts val="800"/>
-              </a:spcAft>
-            </a:pPr>
-            <a:r>
-              <a:rPr sz="1200" b="1">
-                <a:solidFill>
-                  <a:srgbClr val="FFFFFF"/>
-                </a:solidFill>
-                <a:latin typeface="Calibri"/>
-              </a:rPr>
-              <a:t>Add screenshots from the live prototype (suggested captures):</a:t>
-            </a:r>
-          </a:p>
-          <a:p>
-            <a:pPr>
-              <a:spcAft>
-                <a:spcPts val="400"/>
-              </a:spcAft>
-            </a:pPr>
-            <a:r>
-              <a:rPr sz="1150" b="0">
-                <a:solidFill>
-                  <a:srgbClr val="CFD8E6"/>
-                </a:solidFill>
-                <a:latin typeface="Calibri"/>
-              </a:rPr>
-              <a:t>• Chat — English answer + evidence drawer (SQL, rows, case IDs).</a:t>
-            </a:r>
-          </a:p>
-          <a:p>
-            <a:pPr>
-              <a:spcAft>
-                <a:spcPts val="400"/>
-              </a:spcAft>
-            </a:pPr>
-            <a:r>
-              <a:rPr sz="1150" b="0">
-                <a:solidFill>
-                  <a:srgbClr val="CFD8E6"/>
-                </a:solidFill>
-                <a:latin typeface="Calibri"/>
-              </a:rPr>
-              <a:t>• Chat — a Kannada question answered.</a:t>
-            </a:r>
-          </a:p>
-          <a:p>
-            <a:pPr>
-              <a:spcAft>
-                <a:spcPts val="400"/>
-              </a:spcAft>
-            </a:pPr>
-            <a:r>
-              <a:rPr sz="1150" b="0">
-                <a:solidFill>
-                  <a:srgbClr val="CFD8E6"/>
-                </a:solidFill>
-                <a:latin typeface="Calibri"/>
-              </a:rPr>
-              <a:t>• Series — SH-07 discovered (confidence 0.88, 15 linked cases).</a:t>
-            </a:r>
-          </a:p>
-          <a:p>
-            <a:pPr>
-              <a:spcAft>
-                <a:spcPts val="400"/>
-              </a:spcAft>
-            </a:pPr>
-            <a:r>
-              <a:rPr sz="1150" b="0">
-                <a:solidFill>
-                  <a:srgbClr val="CFD8E6"/>
-                </a:solidFill>
-                <a:latin typeface="Calibri"/>
-              </a:rPr>
-              <a:t>• CrimeGraph — the Prakash Rao hub network.</a:t>
-            </a:r>
-          </a:p>
-          <a:p>
-            <a:pPr>
-              <a:spcAft>
-                <a:spcPts val="400"/>
-              </a:spcAft>
-            </a:pPr>
-            <a:r>
-              <a:rPr sz="1150" b="0">
-                <a:solidFill>
-                  <a:srgbClr val="CFD8E6"/>
-                </a:solidFill>
-                <a:latin typeface="Calibri"/>
-              </a:rPr>
-              <a:t>• Investigation Room — six agents streaming, then the assembled pack.</a:t>
-            </a:r>
-          </a:p>
-          <a:p>
-            <a:pPr>
-              <a:spcAft>
-                <a:spcPts val="400"/>
-              </a:spcAft>
-            </a:pPr>
-            <a:r>
-              <a:rPr sz="1150" b="0">
-                <a:solidFill>
-                  <a:srgbClr val="CFD8E6"/>
-                </a:solidFill>
-                <a:latin typeface="Calibri"/>
-              </a:rPr>
-              <a:t>• Lead Feed — Whitefield spike + repeat-offender Lead Cards.</a:t>
-            </a:r>
-          </a:p>
-          <a:p>
-            <a:pPr>
-              <a:spcAft>
-                <a:spcPts val="200"/>
-              </a:spcAft>
-            </a:pPr>
-            <a:r>
-              <a:rPr sz="1100" b="0">
-                <a:solidFill>
-                  <a:srgbClr val="5AB0FF"/>
-                </a:solidFill>
-                <a:latin typeface="Calibri"/>
-              </a:rPr>
-              <a:t>Live app: https://anveshak-api-50044329134.development.catalystappsail.in/ui/</a:t>
+            <a:pPr algn="ctr"/>
+            <a:r>
+              <a:rPr sz="950">
+                <a:solidFill>
+                  <a:srgbClr val="2B374B"/>
+                </a:solidFill>
+                <a:latin typeface="Calibri"/>
+              </a:rPr>
+              <a:t>Night Patrol — proactive leads</a:t>
+            </a:r>
+          </a:p>
+        </p:txBody>
+      </p:sp>
+      <p:pic>
+        <p:nvPicPr>
+          <p:cNvPr id="117" name="Picture 116" descr="02_chat_evidence.png"/>
+          <p:cNvPicPr>
+            <a:picLocks noChangeAspect="1"/>
+          </p:cNvPicPr>
+          <p:nvPr/>
+        </p:nvPicPr>
+        <p:blipFill>
+          <a:blip r:embed="rId5"/>
+          <a:stretch>
+            <a:fillRect/>
+          </a:stretch>
+        </p:blipFill>
+        <p:spPr>
+          <a:xfrm>
+            <a:off x="3209544" y="1353312"/>
+            <a:ext cx="2724912" cy="1532763"/>
+          </a:xfrm>
+          <a:prstGeom prst="rect">
+            <a:avLst/>
+          </a:prstGeom>
+        </p:spPr>
+      </p:pic>
+      <p:sp>
+        <p:nvSpPr>
+          <p:cNvPr id="118" name="TextBox 117"/>
+          <p:cNvSpPr txBox="1"/>
+          <p:nvPr/>
+        </p:nvSpPr>
+        <p:spPr>
+          <a:xfrm>
+            <a:off x="3209544" y="2895219"/>
+            <a:ext cx="2724912" cy="237744"/>
+          </a:xfrm>
+          <a:prstGeom prst="rect">
+            <a:avLst/>
+          </a:prstGeom>
+          <a:noFill/>
+        </p:spPr>
+        <p:txBody>
+          <a:bodyPr wrap="none">
+            <a:spAutoFit/>
+          </a:bodyPr>
+          <a:lstStyle/>
+          <a:p>
+            <a:pPr algn="ctr"/>
+            <a:r>
+              <a:rPr sz="950">
+                <a:solidFill>
+                  <a:srgbClr val="2B374B"/>
+                </a:solidFill>
+                <a:latin typeface="Calibri"/>
+              </a:rPr>
+              <a:t>Chat — answer + evidence (SQL)</a:t>
+            </a:r>
+          </a:p>
+        </p:txBody>
+      </p:sp>
+      <p:pic>
+        <p:nvPicPr>
+          <p:cNvPr id="119" name="Picture 118" descr="03_series.png"/>
+          <p:cNvPicPr>
+            <a:picLocks noChangeAspect="1"/>
+          </p:cNvPicPr>
+          <p:nvPr/>
+        </p:nvPicPr>
+        <p:blipFill>
+          <a:blip r:embed="rId6"/>
+          <a:stretch>
+            <a:fillRect/>
+          </a:stretch>
+        </p:blipFill>
+        <p:spPr>
+          <a:xfrm>
+            <a:off x="6099048" y="1353312"/>
+            <a:ext cx="2724912" cy="1532763"/>
+          </a:xfrm>
+          <a:prstGeom prst="rect">
+            <a:avLst/>
+          </a:prstGeom>
+        </p:spPr>
+      </p:pic>
+      <p:sp>
+        <p:nvSpPr>
+          <p:cNvPr id="120" name="TextBox 119"/>
+          <p:cNvSpPr txBox="1"/>
+          <p:nvPr/>
+        </p:nvSpPr>
+        <p:spPr>
+          <a:xfrm>
+            <a:off x="6099048" y="2895219"/>
+            <a:ext cx="2724912" cy="237744"/>
+          </a:xfrm>
+          <a:prstGeom prst="rect">
+            <a:avLst/>
+          </a:prstGeom>
+          <a:noFill/>
+        </p:spPr>
+        <p:txBody>
+          <a:bodyPr wrap="none">
+            <a:spAutoFit/>
+          </a:bodyPr>
+          <a:lstStyle/>
+          <a:p>
+            <a:pPr algn="ctr"/>
+            <a:r>
+              <a:rPr sz="950">
+                <a:solidFill>
+                  <a:srgbClr val="2B374B"/>
+                </a:solidFill>
+                <a:latin typeface="Calibri"/>
+              </a:rPr>
+              <a:t>Serial linkage — SH-07</a:t>
+            </a:r>
+          </a:p>
+        </p:txBody>
+      </p:sp>
+      <p:pic>
+        <p:nvPicPr>
+          <p:cNvPr id="121" name="Picture 120" descr="04_pack.png"/>
+          <p:cNvPicPr>
+            <a:picLocks noChangeAspect="1"/>
+          </p:cNvPicPr>
+          <p:nvPr/>
+        </p:nvPicPr>
+        <p:blipFill>
+          <a:blip r:embed="rId7"/>
+          <a:stretch>
+            <a:fillRect/>
+          </a:stretch>
+        </p:blipFill>
+        <p:spPr>
+          <a:xfrm>
+            <a:off x="320040" y="3270123"/>
+            <a:ext cx="2724912" cy="1532763"/>
+          </a:xfrm>
+          <a:prstGeom prst="rect">
+            <a:avLst/>
+          </a:prstGeom>
+        </p:spPr>
+      </p:pic>
+      <p:sp>
+        <p:nvSpPr>
+          <p:cNvPr id="122" name="TextBox 121"/>
+          <p:cNvSpPr txBox="1"/>
+          <p:nvPr/>
+        </p:nvSpPr>
+        <p:spPr>
+          <a:xfrm>
+            <a:off x="320040" y="4812030"/>
+            <a:ext cx="2724912" cy="237744"/>
+          </a:xfrm>
+          <a:prstGeom prst="rect">
+            <a:avLst/>
+          </a:prstGeom>
+          <a:noFill/>
+        </p:spPr>
+        <p:txBody>
+          <a:bodyPr wrap="none">
+            <a:spAutoFit/>
+          </a:bodyPr>
+          <a:lstStyle/>
+          <a:p>
+            <a:pPr algn="ctr"/>
+            <a:r>
+              <a:rPr sz="950">
+                <a:solidFill>
+                  <a:srgbClr val="2B374B"/>
+                </a:solidFill>
+                <a:latin typeface="Calibri"/>
+              </a:rPr>
+              <a:t>Investigation Pack — 6 agents</a:t>
+            </a:r>
+          </a:p>
+        </p:txBody>
+      </p:sp>
+      <p:pic>
+        <p:nvPicPr>
+          <p:cNvPr id="123" name="Picture 122" descr="05_graph.png"/>
+          <p:cNvPicPr>
+            <a:picLocks noChangeAspect="1"/>
+          </p:cNvPicPr>
+          <p:nvPr/>
+        </p:nvPicPr>
+        <p:blipFill>
+          <a:blip r:embed="rId8"/>
+          <a:stretch>
+            <a:fillRect/>
+          </a:stretch>
+        </p:blipFill>
+        <p:spPr>
+          <a:xfrm>
+            <a:off x="3209544" y="3270123"/>
+            <a:ext cx="2724912" cy="1532763"/>
+          </a:xfrm>
+          <a:prstGeom prst="rect">
+            <a:avLst/>
+          </a:prstGeom>
+        </p:spPr>
+      </p:pic>
+      <p:sp>
+        <p:nvSpPr>
+          <p:cNvPr id="124" name="TextBox 123"/>
+          <p:cNvSpPr txBox="1"/>
+          <p:nvPr/>
+        </p:nvSpPr>
+        <p:spPr>
+          <a:xfrm>
+            <a:off x="3209544" y="4812030"/>
+            <a:ext cx="2724912" cy="237744"/>
+          </a:xfrm>
+          <a:prstGeom prst="rect">
+            <a:avLst/>
+          </a:prstGeom>
+          <a:noFill/>
+        </p:spPr>
+        <p:txBody>
+          <a:bodyPr wrap="none">
+            <a:spAutoFit/>
+          </a:bodyPr>
+          <a:lstStyle/>
+          <a:p>
+            <a:pPr algn="ctr"/>
+            <a:r>
+              <a:rPr sz="950">
+                <a:solidFill>
+                  <a:srgbClr val="2B374B"/>
+                </a:solidFill>
+                <a:latin typeface="Calibri"/>
+              </a:rPr>
+              <a:t>CrimeGraph — fraud hub</a:t>
+            </a:r>
+          </a:p>
+        </p:txBody>
+      </p:sp>
+      <p:pic>
+        <p:nvPicPr>
+          <p:cNvPr id="125" name="Picture 124" descr="06_kannada.png"/>
+          <p:cNvPicPr>
+            <a:picLocks noChangeAspect="1"/>
+          </p:cNvPicPr>
+          <p:nvPr/>
+        </p:nvPicPr>
+        <p:blipFill>
+          <a:blip r:embed="rId9"/>
+          <a:stretch>
+            <a:fillRect/>
+          </a:stretch>
+        </p:blipFill>
+        <p:spPr>
+          <a:xfrm>
+            <a:off x="6099048" y="3270123"/>
+            <a:ext cx="2724912" cy="1532763"/>
+          </a:xfrm>
+          <a:prstGeom prst="rect">
+            <a:avLst/>
+          </a:prstGeom>
+        </p:spPr>
+      </p:pic>
+      <p:sp>
+        <p:nvSpPr>
+          <p:cNvPr id="126" name="TextBox 125"/>
+          <p:cNvSpPr txBox="1"/>
+          <p:nvPr/>
+        </p:nvSpPr>
+        <p:spPr>
+          <a:xfrm>
+            <a:off x="6099048" y="4812030"/>
+            <a:ext cx="2724912" cy="237744"/>
+          </a:xfrm>
+          <a:prstGeom prst="rect">
+            <a:avLst/>
+          </a:prstGeom>
+          <a:noFill/>
+        </p:spPr>
+        <p:txBody>
+          <a:bodyPr wrap="none">
+            <a:spAutoFit/>
+          </a:bodyPr>
+          <a:lstStyle/>
+          <a:p>
+            <a:pPr algn="ctr"/>
+            <a:r>
+              <a:rPr sz="950">
+                <a:solidFill>
+                  <a:srgbClr val="2B374B"/>
+                </a:solidFill>
+                <a:latin typeface="Calibri"/>
+              </a:rPr>
+              <a:t>Bilingual — ಕನ್ನಡ + English</a:t>
             </a:r>
           </a:p>
         </p:txBody>
@@ -7659,7 +7861,7 @@
             <a:r>
               <a:rPr sz="1100" b="1">
                 <a:solidFill>
-                  <a:srgbClr val="FFFFFF"/>
+                  <a:srgbClr val="0B1F3A"/>
                 </a:solidFill>
                 <a:latin typeface="Calibri"/>
               </a:rPr>
@@ -7668,7 +7870,7 @@
             <a:r>
               <a:rPr sz="1100" b="0">
                 <a:solidFill>
-                  <a:srgbClr val="CFD8E6"/>
+                  <a:srgbClr val="2B374B"/>
                 </a:solidFill>
                 <a:latin typeface="Calibri"/>
               </a:rPr>
@@ -7684,7 +7886,7 @@
             <a:r>
               <a:rPr sz="1100" b="1">
                 <a:solidFill>
-                  <a:srgbClr val="FFFFFF"/>
+                  <a:srgbClr val="0B1F3A"/>
                 </a:solidFill>
                 <a:latin typeface="Calibri"/>
               </a:rPr>
@@ -7693,7 +7895,7 @@
             <a:r>
               <a:rPr sz="1100" b="0">
                 <a:solidFill>
-                  <a:srgbClr val="CFD8E6"/>
+                  <a:srgbClr val="2B374B"/>
                 </a:solidFill>
                 <a:latin typeface="Calibri"/>
               </a:rPr>
@@ -7709,7 +7911,7 @@
             <a:r>
               <a:rPr sz="1100" b="1">
                 <a:solidFill>
-                  <a:srgbClr val="FFFFFF"/>
+                  <a:srgbClr val="0B1F3A"/>
                 </a:solidFill>
                 <a:latin typeface="Calibri"/>
               </a:rPr>
@@ -7718,7 +7920,7 @@
             <a:r>
               <a:rPr sz="1100" b="0">
                 <a:solidFill>
-                  <a:srgbClr val="CFD8E6"/>
+                  <a:srgbClr val="2B374B"/>
                 </a:solidFill>
                 <a:latin typeface="Calibri"/>
               </a:rPr>
@@ -7734,7 +7936,7 @@
             <a:r>
               <a:rPr sz="1100" b="1">
                 <a:solidFill>
-                  <a:srgbClr val="FFFFFF"/>
+                  <a:srgbClr val="0B1F3A"/>
                 </a:solidFill>
                 <a:latin typeface="Calibri"/>
               </a:rPr>
@@ -7743,7 +7945,7 @@
             <a:r>
               <a:rPr sz="1100" b="0">
                 <a:solidFill>
-                  <a:srgbClr val="CFD8E6"/>
+                  <a:srgbClr val="2B374B"/>
                 </a:solidFill>
                 <a:latin typeface="Calibri"/>
               </a:rPr>
@@ -7759,7 +7961,7 @@
             <a:r>
               <a:rPr sz="1100" b="1">
                 <a:solidFill>
-                  <a:srgbClr val="FFFFFF"/>
+                  <a:srgbClr val="0B1F3A"/>
                 </a:solidFill>
                 <a:latin typeface="Calibri"/>
               </a:rPr>
@@ -7768,7 +7970,7 @@
             <a:r>
               <a:rPr sz="1100" b="0">
                 <a:solidFill>
-                  <a:srgbClr val="CFD8E6"/>
+                  <a:srgbClr val="2B374B"/>
                 </a:solidFill>
                 <a:latin typeface="Calibri"/>
               </a:rPr>
@@ -7784,7 +7986,7 @@
             <a:r>
               <a:rPr sz="1100" b="1">
                 <a:solidFill>
-                  <a:srgbClr val="FFFFFF"/>
+                  <a:srgbClr val="0B1F3A"/>
                 </a:solidFill>
                 <a:latin typeface="Calibri"/>
               </a:rPr>
@@ -7793,7 +7995,7 @@
             <a:r>
               <a:rPr sz="1100" b="0">
                 <a:solidFill>
-                  <a:srgbClr val="CFD8E6"/>
+                  <a:srgbClr val="2B374B"/>
                 </a:solidFill>
                 <a:latin typeface="Calibri"/>
               </a:rPr>
@@ -7809,7 +8011,7 @@
             <a:r>
               <a:rPr sz="1100" b="1">
                 <a:solidFill>
-                  <a:srgbClr val="FFFFFF"/>
+                  <a:srgbClr val="0B1F3A"/>
                 </a:solidFill>
                 <a:latin typeface="Calibri"/>
               </a:rPr>
@@ -7818,7 +8020,7 @@
             <a:r>
               <a:rPr sz="1100" b="0">
                 <a:solidFill>
-                  <a:srgbClr val="CFD8E6"/>
+                  <a:srgbClr val="2B374B"/>
                 </a:solidFill>
                 <a:latin typeface="Calibri"/>
               </a:rPr>
@@ -7834,7 +8036,7 @@
             <a:r>
               <a:rPr sz="1000" b="0">
                 <a:solidFill>
-                  <a:srgbClr val="8A97A8"/>
+                  <a:srgbClr val="64748B"/>
                 </a:solidFill>
                 <a:latin typeface="Calibri"/>
               </a:rPr>
@@ -7936,72 +8138,6 @@
             </a:r>
             <a:endParaRPr b="1" sz="1800"/>
           </a:p>
-          <a:p>
-            <a:pPr indent="0" lvl="0" marL="0" rtl="0" algn="l">
-              <a:spcBef>
-                <a:spcPts val="0"/>
-              </a:spcBef>
-              <a:spcAft>
-                <a:spcPts val="0"/>
-              </a:spcAft>
-              <a:buNone/>
-            </a:pPr>
-            <a:r>
-              <a:t/>
-            </a:r>
-            <a:endParaRPr b="1" sz="1800"/>
-          </a:p>
-          <a:p>
-            <a:pPr indent="-342900" lvl="0" marL="457200" rtl="0" algn="l">
-              <a:spcBef>
-                <a:spcPts val="0"/>
-              </a:spcBef>
-              <a:spcAft>
-                <a:spcPts val="0"/>
-              </a:spcAft>
-              <a:buSzPts val="1800"/>
-              <a:buAutoNum type="arabicPeriod"/>
-            </a:pPr>
-            <a:r>
-              <a:rPr b="1" lang="en-GB" sz="1800"/>
-              <a:t>GitHub Public Repository</a:t>
-            </a:r>
-            <a:endParaRPr b="1" sz="1800"/>
-          </a:p>
-          <a:p>
-            <a:pPr indent="-342900" lvl="0" marL="457200" rtl="0" algn="l">
-              <a:spcBef>
-                <a:spcPts val="0"/>
-              </a:spcBef>
-              <a:spcAft>
-                <a:spcPts val="0"/>
-              </a:spcAft>
-              <a:buSzPts val="1800"/>
-              <a:buAutoNum type="arabicPeriod"/>
-            </a:pPr>
-            <a:r>
-              <a:rPr b="1" lang="en-GB" sz="1800"/>
-              <a:t>Demo Video Link (3 Minutes)</a:t>
-            </a:r>
-            <a:endParaRPr b="1" sz="1800"/>
-          </a:p>
-          <a:p>
-            <a:pPr indent="-342900" lvl="0" marL="457200" rtl="0" algn="l">
-              <a:spcBef>
-                <a:spcPts val="0"/>
-              </a:spcBef>
-              <a:spcAft>
-                <a:spcPts val="0"/>
-              </a:spcAft>
-              <a:buSzPts val="1800"/>
-              <a:buAutoNum type="arabicPeriod"/>
-            </a:pPr>
-            <a:r>
-              <a:rPr b="1" lang="en-GB" sz="1800"/>
-              <a:t>Deployed Link</a:t>
-            </a:r>
-            <a:endParaRPr b="1" sz="1800"/>
-          </a:p>
         </p:txBody>
       </p:sp>
       <p:sp>
@@ -8034,7 +8170,7 @@
             <a:r>
               <a:rPr sz="1300" b="1">
                 <a:solidFill>
-                  <a:srgbClr val="FFFFFF"/>
+                  <a:srgbClr val="0B1F3A"/>
                 </a:solidFill>
                 <a:latin typeface="Calibri"/>
               </a:rPr>
@@ -8043,7 +8179,7 @@
             <a:r>
               <a:rPr sz="1300" b="0">
                 <a:solidFill>
-                  <a:srgbClr val="5AB0FF"/>
+                  <a:srgbClr val="1D4ED8"/>
                 </a:solidFill>
                 <a:latin typeface="Calibri"/>
               </a:rPr>
@@ -8059,7 +8195,7 @@
             <a:r>
               <a:rPr sz="1300" b="1">
                 <a:solidFill>
-                  <a:srgbClr val="FFFFFF"/>
+                  <a:srgbClr val="0B1F3A"/>
                 </a:solidFill>
                 <a:latin typeface="Calibri"/>
               </a:rPr>
@@ -8068,7 +8204,7 @@
             <a:r>
               <a:rPr sz="1300" b="0">
                 <a:solidFill>
-                  <a:srgbClr val="5AB0FF"/>
+                  <a:srgbClr val="1D4ED8"/>
                 </a:solidFill>
                 <a:latin typeface="Calibri"/>
               </a:rPr>
@@ -8084,7 +8220,7 @@
             <a:r>
               <a:rPr sz="1300" b="1">
                 <a:solidFill>
-                  <a:srgbClr val="FFFFFF"/>
+                  <a:srgbClr val="0B1F3A"/>
                 </a:solidFill>
                 <a:latin typeface="Calibri"/>
               </a:rPr>
@@ -8093,7 +8229,7 @@
             <a:r>
               <a:rPr sz="1300" b="0">
                 <a:solidFill>
-                  <a:srgbClr val="8A97A8"/>
+                  <a:srgbClr val="64748B"/>
                 </a:solidFill>
                 <a:latin typeface="Calibri"/>
               </a:rPr>
@@ -8109,7 +8245,7 @@
             <a:r>
               <a:rPr sz="1000" b="0">
                 <a:solidFill>
-                  <a:srgbClr val="8A97A8"/>
+                  <a:srgbClr val="64748B"/>
                 </a:solidFill>
                 <a:latin typeface="Calibri"/>
               </a:rPr>
@@ -8243,7 +8379,7 @@
             <a:r>
               <a:rPr sz="1200" b="1">
                 <a:solidFill>
-                  <a:srgbClr val="FFFFFF"/>
+                  <a:srgbClr val="0B1F3A"/>
                 </a:solidFill>
                 <a:latin typeface="Calibri"/>
               </a:rPr>
@@ -8259,7 +8395,7 @@
             <a:r>
               <a:rPr sz="1150" b="0">
                 <a:solidFill>
-                  <a:srgbClr val="CFD8E6"/>
+                  <a:srgbClr val="2B374B"/>
                 </a:solidFill>
                 <a:latin typeface="Calibri"/>
               </a:rPr>
@@ -8275,7 +8411,7 @@
             <a:r>
               <a:rPr sz="1150" b="0">
                 <a:solidFill>
-                  <a:srgbClr val="CFD8E6"/>
+                  <a:srgbClr val="2B374B"/>
                 </a:solidFill>
                 <a:latin typeface="Calibri"/>
               </a:rPr>
@@ -8291,7 +8427,7 @@
             <a:r>
               <a:rPr sz="1150" b="0">
                 <a:solidFill>
-                  <a:srgbClr val="CFD8E6"/>
+                  <a:srgbClr val="2B374B"/>
                 </a:solidFill>
                 <a:latin typeface="Calibri"/>
               </a:rPr>
@@ -8307,7 +8443,7 @@
             <a:r>
               <a:rPr sz="1150" b="0">
                 <a:solidFill>
-                  <a:srgbClr val="CFD8E6"/>
+                  <a:srgbClr val="2B374B"/>
                 </a:solidFill>
                 <a:latin typeface="Calibri"/>
               </a:rPr>
@@ -8323,7 +8459,7 @@
             <a:r>
               <a:rPr sz="1150" b="0">
                 <a:solidFill>
-                  <a:srgbClr val="CFD8E6"/>
+                  <a:srgbClr val="2B374B"/>
                 </a:solidFill>
                 <a:latin typeface="Calibri"/>
               </a:rPr>
@@ -8339,7 +8475,7 @@
             <a:r>
               <a:rPr sz="1150" b="0">
                 <a:solidFill>
-                  <a:srgbClr val="CFD8E6"/>
+                  <a:srgbClr val="2B374B"/>
                 </a:solidFill>
                 <a:latin typeface="Calibri"/>
               </a:rPr>
@@ -8621,7 +8757,7 @@
             <a:r>
               <a:rPr sz="1300" b="1">
                 <a:solidFill>
-                  <a:srgbClr val="FFFFFF"/>
+                  <a:srgbClr val="0B1F3A"/>
                 </a:solidFill>
                 <a:latin typeface="Calibri"/>
               </a:rPr>
@@ -8630,7 +8766,7 @@
             <a:r>
               <a:rPr sz="1300" b="0">
                 <a:solidFill>
-                  <a:srgbClr val="CFD8E6"/>
+                  <a:srgbClr val="2B374B"/>
                 </a:solidFill>
                 <a:latin typeface="Calibri"/>
               </a:rPr>
@@ -8639,7 +8775,7 @@
             <a:r>
               <a:rPr sz="1300" b="1">
                 <a:solidFill>
-                  <a:srgbClr val="FFFFFF"/>
+                  <a:srgbClr val="0B1F3A"/>
                 </a:solidFill>
                 <a:latin typeface="Calibri"/>
               </a:rPr>
@@ -8648,7 +8784,7 @@
             <a:r>
               <a:rPr sz="1300" b="0">
                 <a:solidFill>
-                  <a:srgbClr val="CFD8E6"/>
+                  <a:srgbClr val="2B374B"/>
                 </a:solidFill>
                 <a:latin typeface="Calibri"/>
               </a:rPr>
@@ -8664,7 +8800,7 @@
             <a:r>
               <a:rPr sz="1200" b="0">
                 <a:solidFill>
-                  <a:srgbClr val="CFD8E6"/>
+                  <a:srgbClr val="2B374B"/>
                 </a:solidFill>
                 <a:latin typeface="Calibri"/>
               </a:rPr>
@@ -8673,7 +8809,7 @@
             <a:r>
               <a:rPr sz="1200" b="1">
                 <a:solidFill>
-                  <a:srgbClr val="FFFFFF"/>
+                  <a:srgbClr val="0B1F3A"/>
                 </a:solidFill>
                 <a:latin typeface="Calibri"/>
               </a:rPr>
@@ -8682,7 +8818,7 @@
             <a:r>
               <a:rPr sz="1200" b="0">
                 <a:solidFill>
-                  <a:srgbClr val="CFD8E6"/>
+                  <a:srgbClr val="2B374B"/>
                 </a:solidFill>
                 <a:latin typeface="Calibri"/>
               </a:rPr>
@@ -8698,7 +8834,7 @@
             <a:r>
               <a:rPr sz="1200" b="1">
                 <a:solidFill>
-                  <a:srgbClr val="FFFFFF"/>
+                  <a:srgbClr val="0B1F3A"/>
                 </a:solidFill>
                 <a:latin typeface="Calibri"/>
               </a:rPr>
@@ -8707,7 +8843,7 @@
             <a:r>
               <a:rPr sz="1200" b="0">
                 <a:solidFill>
-                  <a:srgbClr val="CFD8E6"/>
+                  <a:srgbClr val="2B374B"/>
                 </a:solidFill>
                 <a:latin typeface="Calibri"/>
               </a:rPr>
@@ -8723,7 +8859,7 @@
             <a:r>
               <a:rPr sz="1200" b="0">
                 <a:solidFill>
-                  <a:srgbClr val="CFD8E6"/>
+                  <a:srgbClr val="2B374B"/>
                 </a:solidFill>
                 <a:latin typeface="Calibri"/>
               </a:rPr>
@@ -8739,7 +8875,7 @@
             <a:r>
               <a:rPr sz="1200" b="1">
                 <a:solidFill>
-                  <a:srgbClr val="FFFFFF"/>
+                  <a:srgbClr val="0B1F3A"/>
                 </a:solidFill>
                 <a:latin typeface="Calibri"/>
               </a:rPr>
@@ -8748,7 +8884,7 @@
             <a:r>
               <a:rPr sz="1200" b="1">
                 <a:solidFill>
-                  <a:srgbClr val="5AD69C"/>
+                  <a:srgbClr val="047855"/>
                 </a:solidFill>
                 <a:latin typeface="Calibri"/>
               </a:rPr>
@@ -8861,118 +8997,6 @@
               </a:solidFill>
             </a:endParaRPr>
           </a:p>
-          <a:p>
-            <a:pPr indent="-330200" lvl="1" marL="914400" rtl="0" algn="l">
-              <a:lnSpc>
-                <a:spcPct val="115000"/>
-              </a:lnSpc>
-              <a:spcBef>
-                <a:spcPts val="0"/>
-              </a:spcBef>
-              <a:spcAft>
-                <a:spcPts val="0"/>
-              </a:spcAft>
-              <a:buClr>
-                <a:srgbClr val="000000"/>
-              </a:buClr>
-              <a:buSzPts val="1600"/>
-              <a:buAutoNum type="alphaLcPeriod"/>
-            </a:pPr>
-            <a:r>
-              <a:rPr b="1" lang="en-GB" sz="1600">
-                <a:solidFill>
-                  <a:srgbClr val="000000"/>
-                </a:solidFill>
-              </a:rPr>
-              <a:t>How different is it from any of the other existing ideas?</a:t>
-            </a:r>
-            <a:endParaRPr b="1" sz="1600">
-              <a:solidFill>
-                <a:srgbClr val="000000"/>
-              </a:solidFill>
-            </a:endParaRPr>
-          </a:p>
-          <a:p>
-            <a:pPr indent="-330200" lvl="1" marL="914400" rtl="0" algn="l">
-              <a:lnSpc>
-                <a:spcPct val="115000"/>
-              </a:lnSpc>
-              <a:spcBef>
-                <a:spcPts val="0"/>
-              </a:spcBef>
-              <a:spcAft>
-                <a:spcPts val="0"/>
-              </a:spcAft>
-              <a:buClr>
-                <a:srgbClr val="000000"/>
-              </a:buClr>
-              <a:buSzPts val="1600"/>
-              <a:buAutoNum type="alphaLcPeriod"/>
-            </a:pPr>
-            <a:r>
-              <a:rPr b="1" lang="en-GB" sz="1600">
-                <a:solidFill>
-                  <a:srgbClr val="000000"/>
-                </a:solidFill>
-              </a:rPr>
-              <a:t>How will it be able to solve the problem?</a:t>
-            </a:r>
-            <a:endParaRPr b="1" sz="1600">
-              <a:solidFill>
-                <a:srgbClr val="000000"/>
-              </a:solidFill>
-            </a:endParaRPr>
-          </a:p>
-          <a:p>
-            <a:pPr indent="-330200" lvl="1" marL="914400" rtl="0" algn="l">
-              <a:lnSpc>
-                <a:spcPct val="115000"/>
-              </a:lnSpc>
-              <a:spcBef>
-                <a:spcPts val="0"/>
-              </a:spcBef>
-              <a:spcAft>
-                <a:spcPts val="0"/>
-              </a:spcAft>
-              <a:buClr>
-                <a:srgbClr val="000000"/>
-              </a:buClr>
-              <a:buSzPts val="1600"/>
-              <a:buAutoNum type="alphaLcPeriod"/>
-            </a:pPr>
-            <a:r>
-              <a:rPr b="1" lang="en-GB" sz="1600">
-                <a:solidFill>
-                  <a:srgbClr val="000000"/>
-                </a:solidFill>
-              </a:rPr>
-              <a:t>USP of the proposed solution</a:t>
-            </a:r>
-            <a:endParaRPr b="1" sz="1600">
-              <a:solidFill>
-                <a:srgbClr val="000000"/>
-              </a:solidFill>
-            </a:endParaRPr>
-          </a:p>
-          <a:p>
-            <a:pPr indent="0" lvl="0" marL="0" rtl="0" algn="l">
-              <a:spcBef>
-                <a:spcPts val="0"/>
-              </a:spcBef>
-              <a:spcAft>
-                <a:spcPts val="0"/>
-              </a:spcAft>
-              <a:buNone/>
-            </a:pPr>
-            <a:r>
-              <a:t/>
-            </a:r>
-            <a:endParaRPr b="1" sz="1600">
-              <a:solidFill>
-                <a:srgbClr val="595959"/>
-              </a:solidFill>
-            </a:endParaRPr>
-          </a:p>
         </p:txBody>
       </p:sp>
       <p:sp>
@@ -9005,7 +9029,7 @@
             <a:r>
               <a:rPr sz="1200" b="1">
                 <a:solidFill>
-                  <a:srgbClr val="FFFFFF"/>
+                  <a:srgbClr val="0B1F3A"/>
                 </a:solidFill>
                 <a:latin typeface="Calibri"/>
               </a:rPr>
@@ -9021,7 +9045,7 @@
             <a:r>
               <a:rPr sz="1200" b="0">
                 <a:solidFill>
-                  <a:srgbClr val="CFD8E6"/>
+                  <a:srgbClr val="2B374B"/>
                 </a:solidFill>
                 <a:latin typeface="Calibri"/>
               </a:rPr>
@@ -9037,7 +9061,7 @@
             <a:r>
               <a:rPr sz="1200" b="1">
                 <a:solidFill>
-                  <a:srgbClr val="FFFFFF"/>
+                  <a:srgbClr val="0B1F3A"/>
                 </a:solidFill>
                 <a:latin typeface="Calibri"/>
               </a:rPr>
@@ -9046,7 +9070,7 @@
             <a:r>
               <a:rPr sz="1200" b="0">
                 <a:solidFill>
-                  <a:srgbClr val="CFD8E6"/>
+                  <a:srgbClr val="2B374B"/>
                 </a:solidFill>
                 <a:latin typeface="Calibri"/>
               </a:rPr>
@@ -9062,7 +9086,7 @@
             <a:r>
               <a:rPr sz="1200" b="1">
                 <a:solidFill>
-                  <a:srgbClr val="FFFFFF"/>
+                  <a:srgbClr val="0B1F3A"/>
                 </a:solidFill>
                 <a:latin typeface="Calibri"/>
               </a:rPr>
@@ -9071,7 +9095,7 @@
             <a:r>
               <a:rPr sz="1200" b="0">
                 <a:solidFill>
-                  <a:srgbClr val="CFD8E6"/>
+                  <a:srgbClr val="2B374B"/>
                 </a:solidFill>
                 <a:latin typeface="Calibri"/>
               </a:rPr>
@@ -9087,7 +9111,7 @@
             <a:r>
               <a:rPr sz="1200" b="1">
                 <a:solidFill>
-                  <a:srgbClr val="FFFFFF"/>
+                  <a:srgbClr val="0B1F3A"/>
                 </a:solidFill>
                 <a:latin typeface="Calibri"/>
               </a:rPr>
@@ -9096,7 +9120,7 @@
             <a:r>
               <a:rPr sz="1200" b="0">
                 <a:solidFill>
-                  <a:srgbClr val="CFD8E6"/>
+                  <a:srgbClr val="2B374B"/>
                 </a:solidFill>
                 <a:latin typeface="Calibri"/>
               </a:rPr>
@@ -9112,7 +9136,7 @@
             <a:r>
               <a:rPr sz="1100" b="1">
                 <a:solidFill>
-                  <a:srgbClr val="FFFFFF"/>
+                  <a:srgbClr val="0B1F3A"/>
                 </a:solidFill>
                 <a:latin typeface="Calibri"/>
               </a:rPr>
@@ -9121,7 +9145,7 @@
             <a:r>
               <a:rPr sz="1100" b="0">
                 <a:solidFill>
-                  <a:srgbClr val="CFD8E6"/>
+                  <a:srgbClr val="2B374B"/>
                 </a:solidFill>
                 <a:latin typeface="Calibri"/>
               </a:rPr>
@@ -9137,7 +9161,7 @@
             <a:r>
               <a:rPr sz="1150" b="1">
                 <a:solidFill>
-                  <a:srgbClr val="5AB0FF"/>
+                  <a:srgbClr val="1D4ED8"/>
                 </a:solidFill>
                 <a:latin typeface="Calibri"/>
               </a:rPr>
@@ -9146,7 +9170,7 @@
             <a:r>
               <a:rPr sz="1150" b="0">
                 <a:solidFill>
-                  <a:srgbClr val="FFFFFF"/>
+                  <a:srgbClr val="0B1F3A"/>
                 </a:solidFill>
                 <a:latin typeface="Calibri"/>
               </a:rPr>
@@ -9280,7 +9304,7 @@
             <a:r>
               <a:rPr sz="1150" b="1">
                 <a:solidFill>
-                  <a:srgbClr val="FFFFFF"/>
+                  <a:srgbClr val="0B1F3A"/>
                 </a:solidFill>
                 <a:latin typeface="Calibri"/>
               </a:rPr>
@@ -9289,7 +9313,7 @@
             <a:r>
               <a:rPr sz="1150" b="0">
                 <a:solidFill>
-                  <a:srgbClr val="CFD8E6"/>
+                  <a:srgbClr val="2B374B"/>
                 </a:solidFill>
                 <a:latin typeface="Calibri"/>
               </a:rPr>
@@ -9305,7 +9329,7 @@
             <a:r>
               <a:rPr sz="1150" b="1">
                 <a:solidFill>
-                  <a:srgbClr val="FFFFFF"/>
+                  <a:srgbClr val="0B1F3A"/>
                 </a:solidFill>
                 <a:latin typeface="Calibri"/>
               </a:rPr>
@@ -9314,7 +9338,7 @@
             <a:r>
               <a:rPr sz="1150" b="0">
                 <a:solidFill>
-                  <a:srgbClr val="CFD8E6"/>
+                  <a:srgbClr val="2B374B"/>
                 </a:solidFill>
                 <a:latin typeface="Calibri"/>
               </a:rPr>
@@ -9330,7 +9354,7 @@
             <a:r>
               <a:rPr sz="1150" b="1">
                 <a:solidFill>
-                  <a:srgbClr val="FFFFFF"/>
+                  <a:srgbClr val="0B1F3A"/>
                 </a:solidFill>
                 <a:latin typeface="Calibri"/>
               </a:rPr>
@@ -9339,7 +9363,7 @@
             <a:r>
               <a:rPr sz="1150" b="0">
                 <a:solidFill>
-                  <a:srgbClr val="CFD8E6"/>
+                  <a:srgbClr val="2B374B"/>
                 </a:solidFill>
                 <a:latin typeface="Calibri"/>
               </a:rPr>
@@ -9355,7 +9379,7 @@
             <a:r>
               <a:rPr sz="1150" b="1">
                 <a:solidFill>
-                  <a:srgbClr val="FFFFFF"/>
+                  <a:srgbClr val="0B1F3A"/>
                 </a:solidFill>
                 <a:latin typeface="Calibri"/>
               </a:rPr>
@@ -9364,7 +9388,7 @@
             <a:r>
               <a:rPr sz="1150" b="0">
                 <a:solidFill>
-                  <a:srgbClr val="CFD8E6"/>
+                  <a:srgbClr val="2B374B"/>
                 </a:solidFill>
                 <a:latin typeface="Calibri"/>
               </a:rPr>
@@ -9380,7 +9404,7 @@
             <a:r>
               <a:rPr sz="1150" b="1">
                 <a:solidFill>
-                  <a:srgbClr val="FFFFFF"/>
+                  <a:srgbClr val="0B1F3A"/>
                 </a:solidFill>
                 <a:latin typeface="Calibri"/>
               </a:rPr>
@@ -9389,7 +9413,7 @@
             <a:r>
               <a:rPr sz="1150" b="0">
                 <a:solidFill>
-                  <a:srgbClr val="CFD8E6"/>
+                  <a:srgbClr val="2B374B"/>
                 </a:solidFill>
                 <a:latin typeface="Calibri"/>
               </a:rPr>
@@ -9405,7 +9429,7 @@
             <a:r>
               <a:rPr sz="1150" b="1">
                 <a:solidFill>
-                  <a:srgbClr val="FFFFFF"/>
+                  <a:srgbClr val="0B1F3A"/>
                 </a:solidFill>
                 <a:latin typeface="Calibri"/>
               </a:rPr>
@@ -9414,7 +9438,7 @@
             <a:r>
               <a:rPr sz="1150" b="0">
                 <a:solidFill>
-                  <a:srgbClr val="CFD8E6"/>
+                  <a:srgbClr val="2B374B"/>
                 </a:solidFill>
                 <a:latin typeface="Calibri"/>
               </a:rPr>
@@ -9430,7 +9454,7 @@
             <a:r>
               <a:rPr sz="1150" b="1">
                 <a:solidFill>
-                  <a:srgbClr val="FFFFFF"/>
+                  <a:srgbClr val="0B1F3A"/>
                 </a:solidFill>
                 <a:latin typeface="Calibri"/>
               </a:rPr>
@@ -9439,7 +9463,7 @@
             <a:r>
               <a:rPr sz="1150" b="0">
                 <a:solidFill>
-                  <a:srgbClr val="CFD8E6"/>
+                  <a:srgbClr val="2B374B"/>
                 </a:solidFill>
                 <a:latin typeface="Calibri"/>
               </a:rPr>
@@ -9573,7 +9597,7 @@
             <a:r>
               <a:rPr sz="1200" b="1">
                 <a:solidFill>
-                  <a:srgbClr val="FFFFFF"/>
+                  <a:srgbClr val="0B1F3A"/>
                 </a:solidFill>
                 <a:latin typeface="Calibri"/>
               </a:rPr>
@@ -9589,7 +9613,7 @@
             <a:r>
               <a:rPr sz="1200" b="1">
                 <a:solidFill>
-                  <a:srgbClr val="5AB0FF"/>
+                  <a:srgbClr val="1D4ED8"/>
                 </a:solidFill>
                 <a:latin typeface="Calibri"/>
               </a:rPr>
@@ -9598,7 +9622,7 @@
             <a:r>
               <a:rPr sz="1200" b="0">
                 <a:solidFill>
-                  <a:srgbClr val="CFD8E6"/>
+                  <a:srgbClr val="2B374B"/>
                 </a:solidFill>
                 <a:latin typeface="Calibri"/>
               </a:rPr>
@@ -9614,7 +9638,7 @@
             <a:r>
               <a:rPr sz="1200" b="1">
                 <a:solidFill>
-                  <a:srgbClr val="5AB0FF"/>
+                  <a:srgbClr val="1D4ED8"/>
                 </a:solidFill>
                 <a:latin typeface="Calibri"/>
               </a:rPr>
@@ -9623,7 +9647,7 @@
             <a:r>
               <a:rPr sz="1200" b="0">
                 <a:solidFill>
-                  <a:srgbClr val="CFD8E6"/>
+                  <a:srgbClr val="2B374B"/>
                 </a:solidFill>
                 <a:latin typeface="Calibri"/>
               </a:rPr>
@@ -9639,7 +9663,7 @@
             <a:r>
               <a:rPr sz="1200" b="1">
                 <a:solidFill>
-                  <a:srgbClr val="5AB0FF"/>
+                  <a:srgbClr val="1D4ED8"/>
                 </a:solidFill>
                 <a:latin typeface="Calibri"/>
               </a:rPr>
@@ -9648,7 +9672,7 @@
             <a:r>
               <a:rPr sz="1200" b="0">
                 <a:solidFill>
-                  <a:srgbClr val="CFD8E6"/>
+                  <a:srgbClr val="2B374B"/>
                 </a:solidFill>
                 <a:latin typeface="Calibri"/>
               </a:rPr>
@@ -9664,7 +9688,7 @@
             <a:r>
               <a:rPr sz="1200" b="1">
                 <a:solidFill>
-                  <a:srgbClr val="5AB0FF"/>
+                  <a:srgbClr val="1D4ED8"/>
                 </a:solidFill>
                 <a:latin typeface="Calibri"/>
               </a:rPr>
@@ -9673,7 +9697,7 @@
             <a:r>
               <a:rPr sz="1200" b="0">
                 <a:solidFill>
-                  <a:srgbClr val="CFD8E6"/>
+                  <a:srgbClr val="2B374B"/>
                 </a:solidFill>
                 <a:latin typeface="Calibri"/>
               </a:rPr>
@@ -9689,7 +9713,7 @@
             <a:r>
               <a:rPr sz="1100" b="1">
                 <a:solidFill>
-                  <a:srgbClr val="FFFFFF"/>
+                  <a:srgbClr val="0B1F3A"/>
                 </a:solidFill>
                 <a:latin typeface="Calibri"/>
               </a:rPr>
@@ -9698,7 +9722,7 @@
             <a:r>
               <a:rPr sz="1100" b="0">
                 <a:solidFill>
-                  <a:srgbClr val="CFD8E6"/>
+                  <a:srgbClr val="2B374B"/>
                 </a:solidFill>
                 <a:latin typeface="Calibri"/>
               </a:rPr>
@@ -9832,7 +9856,7 @@
             <a:r>
               <a:rPr sz="1200" b="1">
                 <a:solidFill>
-                  <a:srgbClr val="FFFFFF"/>
+                  <a:srgbClr val="0B1F3A"/>
                 </a:solidFill>
                 <a:latin typeface="Calibri"/>
               </a:rPr>
@@ -9848,7 +9872,7 @@
             <a:r>
               <a:rPr sz="1150" b="1">
                 <a:solidFill>
-                  <a:srgbClr val="FFFFFF"/>
+                  <a:srgbClr val="0B1F3A"/>
                 </a:solidFill>
                 <a:latin typeface="Calibri"/>
               </a:rPr>
@@ -9857,7 +9881,7 @@
             <a:r>
               <a:rPr sz="1150" b="0">
                 <a:solidFill>
-                  <a:srgbClr val="CFD8E6"/>
+                  <a:srgbClr val="2B374B"/>
                 </a:solidFill>
                 <a:latin typeface="Calibri"/>
               </a:rPr>
@@ -9873,7 +9897,7 @@
             <a:r>
               <a:rPr sz="1150" b="1">
                 <a:solidFill>
-                  <a:srgbClr val="FFFFFF"/>
+                  <a:srgbClr val="0B1F3A"/>
                 </a:solidFill>
                 <a:latin typeface="Calibri"/>
               </a:rPr>
@@ -9882,7 +9906,7 @@
             <a:r>
               <a:rPr sz="1150" b="0">
                 <a:solidFill>
-                  <a:srgbClr val="CFD8E6"/>
+                  <a:srgbClr val="2B374B"/>
                 </a:solidFill>
                 <a:latin typeface="Calibri"/>
               </a:rPr>
@@ -9898,7 +9922,7 @@
             <a:r>
               <a:rPr sz="1150" b="1">
                 <a:solidFill>
-                  <a:srgbClr val="FFFFFF"/>
+                  <a:srgbClr val="0B1F3A"/>
                 </a:solidFill>
                 <a:latin typeface="Calibri"/>
               </a:rPr>
@@ -9907,7 +9931,7 @@
             <a:r>
               <a:rPr sz="1150" b="0">
                 <a:solidFill>
-                  <a:srgbClr val="CFD8E6"/>
+                  <a:srgbClr val="2B374B"/>
                 </a:solidFill>
                 <a:latin typeface="Calibri"/>
               </a:rPr>
@@ -9923,7 +9947,7 @@
             <a:r>
               <a:rPr sz="1150" b="1">
                 <a:solidFill>
-                  <a:srgbClr val="FFFFFF"/>
+                  <a:srgbClr val="0B1F3A"/>
                 </a:solidFill>
                 <a:latin typeface="Calibri"/>
               </a:rPr>
@@ -9932,7 +9956,7 @@
             <a:r>
               <a:rPr sz="1150" b="0">
                 <a:solidFill>
-                  <a:srgbClr val="CFD8E6"/>
+                  <a:srgbClr val="2B374B"/>
                 </a:solidFill>
                 <a:latin typeface="Calibri"/>
               </a:rPr>
@@ -9948,7 +9972,7 @@
             <a:r>
               <a:rPr sz="1150" b="1">
                 <a:solidFill>
-                  <a:srgbClr val="FFFFFF"/>
+                  <a:srgbClr val="0B1F3A"/>
                 </a:solidFill>
                 <a:latin typeface="Calibri"/>
               </a:rPr>
@@ -9957,7 +9981,7 @@
             <a:r>
               <a:rPr sz="1150" b="0">
                 <a:solidFill>
-                  <a:srgbClr val="CFD8E6"/>
+                  <a:srgbClr val="2B374B"/>
                 </a:solidFill>
                 <a:latin typeface="Calibri"/>
               </a:rPr>
@@ -9973,7 +9997,7 @@
             <a:r>
               <a:rPr sz="1150" b="1">
                 <a:solidFill>
-                  <a:srgbClr val="FFFFFF"/>
+                  <a:srgbClr val="0B1F3A"/>
                 </a:solidFill>
                 <a:latin typeface="Calibri"/>
               </a:rPr>
@@ -9982,7 +10006,7 @@
             <a:r>
               <a:rPr sz="1150" b="0">
                 <a:solidFill>
-                  <a:srgbClr val="CFD8E6"/>
+                  <a:srgbClr val="2B374B"/>
                 </a:solidFill>
                 <a:latin typeface="Calibri"/>
               </a:rPr>
@@ -9998,7 +10022,7 @@
             <a:r>
               <a:rPr sz="1100" b="0">
                 <a:solidFill>
-                  <a:srgbClr val="5AB0FF"/>
+                  <a:srgbClr val="1D4ED8"/>
                 </a:solidFill>
                 <a:latin typeface="Calibri"/>
               </a:rPr>
@@ -10132,7 +10156,7 @@
             <a:r>
               <a:rPr sz="1100" b="0">
                 <a:solidFill>
-                  <a:srgbClr val="CFD8E6"/>
+                  <a:srgbClr val="2B374B"/>
                 </a:solidFill>
                 <a:latin typeface="Calibri"/>
               </a:rPr>
@@ -10148,7 +10172,7 @@
             <a:r>
               <a:rPr sz="1100" b="0">
                 <a:solidFill>
-                  <a:srgbClr val="CFD8E6"/>
+                  <a:srgbClr val="2B374B"/>
                 </a:solidFill>
                 <a:latin typeface="Calibri"/>
               </a:rPr>
@@ -10164,7 +10188,7 @@
             <a:r>
               <a:rPr sz="1100" b="0">
                 <a:solidFill>
-                  <a:srgbClr val="CFD8E6"/>
+                  <a:srgbClr val="2B374B"/>
                 </a:solidFill>
                 <a:latin typeface="Calibri"/>
               </a:rPr>
@@ -10180,7 +10204,7 @@
             <a:r>
               <a:rPr sz="1100" b="0">
                 <a:solidFill>
-                  <a:srgbClr val="8A97A8"/>
+                  <a:srgbClr val="64748B"/>
                 </a:solidFill>
                 <a:latin typeface="Calibri"/>
               </a:rPr>
@@ -10196,7 +10220,7 @@
             <a:r>
               <a:rPr sz="1100" b="0">
                 <a:solidFill>
-                  <a:srgbClr val="8A97A8"/>
+                  <a:srgbClr val="64748B"/>
                 </a:solidFill>
                 <a:latin typeface="Calibri"/>
               </a:rPr>
@@ -10212,7 +10236,7 @@
             <a:r>
               <a:rPr sz="1100" b="0">
                 <a:solidFill>
-                  <a:srgbClr val="CFD8E6"/>
+                  <a:srgbClr val="2B374B"/>
                 </a:solidFill>
                 <a:latin typeface="Calibri"/>
               </a:rPr>
@@ -10228,7 +10252,7 @@
             <a:r>
               <a:rPr sz="1100" b="0">
                 <a:solidFill>
-                  <a:srgbClr val="CFD8E6"/>
+                  <a:srgbClr val="2B374B"/>
                 </a:solidFill>
                 <a:latin typeface="Calibri"/>
               </a:rPr>
@@ -10244,7 +10268,7 @@
             <a:r>
               <a:rPr sz="1100" b="0">
                 <a:solidFill>
-                  <a:srgbClr val="CFD8E6"/>
+                  <a:srgbClr val="2B374B"/>
                 </a:solidFill>
                 <a:latin typeface="Calibri"/>
               </a:rPr>
@@ -10260,7 +10284,7 @@
             <a:r>
               <a:rPr sz="1100" b="0">
                 <a:solidFill>
-                  <a:srgbClr val="CFD8E6"/>
+                  <a:srgbClr val="2B374B"/>
                 </a:solidFill>
                 <a:latin typeface="Calibri"/>
               </a:rPr>
@@ -10276,7 +10300,7 @@
             <a:r>
               <a:rPr sz="1050" b="1">
                 <a:solidFill>
-                  <a:srgbClr val="FFFFFF"/>
+                  <a:srgbClr val="0B1F3A"/>
                 </a:solidFill>
                 <a:latin typeface="Calibri"/>
               </a:rPr>
@@ -10285,7 +10309,7 @@
             <a:r>
               <a:rPr sz="1050" b="0">
                 <a:solidFill>
-                  <a:srgbClr val="CFD8E6"/>
+                  <a:srgbClr val="2B374B"/>
                 </a:solidFill>
                 <a:latin typeface="Calibri"/>
               </a:rPr>
@@ -10419,7 +10443,7 @@
             <a:r>
               <a:rPr sz="1150" b="1">
                 <a:solidFill>
-                  <a:srgbClr val="FFFFFF"/>
+                  <a:srgbClr val="0B1F3A"/>
                 </a:solidFill>
                 <a:latin typeface="Calibri"/>
               </a:rPr>
@@ -10428,7 +10452,7 @@
             <a:r>
               <a:rPr sz="1150" b="0">
                 <a:solidFill>
-                  <a:srgbClr val="CFD8E6"/>
+                  <a:srgbClr val="2B374B"/>
                 </a:solidFill>
                 <a:latin typeface="Calibri"/>
               </a:rPr>
@@ -10444,7 +10468,7 @@
             <a:r>
               <a:rPr sz="1150" b="1">
                 <a:solidFill>
-                  <a:srgbClr val="FFFFFF"/>
+                  <a:srgbClr val="0B1F3A"/>
                 </a:solidFill>
                 <a:latin typeface="Calibri"/>
               </a:rPr>
@@ -10453,7 +10477,7 @@
             <a:r>
               <a:rPr sz="1150" b="0">
                 <a:solidFill>
-                  <a:srgbClr val="CFD8E6"/>
+                  <a:srgbClr val="2B374B"/>
                 </a:solidFill>
                 <a:latin typeface="Calibri"/>
               </a:rPr>
@@ -10469,7 +10493,7 @@
             <a:r>
               <a:rPr sz="1150" b="1">
                 <a:solidFill>
-                  <a:srgbClr val="FFFFFF"/>
+                  <a:srgbClr val="0B1F3A"/>
                 </a:solidFill>
                 <a:latin typeface="Calibri"/>
               </a:rPr>
@@ -10478,7 +10502,7 @@
             <a:r>
               <a:rPr sz="1150" b="0">
                 <a:solidFill>
-                  <a:srgbClr val="CFD8E6"/>
+                  <a:srgbClr val="2B374B"/>
                 </a:solidFill>
                 <a:latin typeface="Calibri"/>
               </a:rPr>
@@ -10494,7 +10518,7 @@
             <a:r>
               <a:rPr sz="1150" b="1">
                 <a:solidFill>
-                  <a:srgbClr val="FFFFFF"/>
+                  <a:srgbClr val="0B1F3A"/>
                 </a:solidFill>
                 <a:latin typeface="Calibri"/>
               </a:rPr>
@@ -10503,7 +10527,7 @@
             <a:r>
               <a:rPr sz="1150" b="0">
                 <a:solidFill>
-                  <a:srgbClr val="CFD8E6"/>
+                  <a:srgbClr val="2B374B"/>
                 </a:solidFill>
                 <a:latin typeface="Calibri"/>
               </a:rPr>
@@ -10519,7 +10543,7 @@
             <a:r>
               <a:rPr sz="1150" b="1">
                 <a:solidFill>
-                  <a:srgbClr val="FFFFFF"/>
+                  <a:srgbClr val="0B1F3A"/>
                 </a:solidFill>
                 <a:latin typeface="Calibri"/>
               </a:rPr>
@@ -10528,7 +10552,7 @@
             <a:r>
               <a:rPr sz="1150" b="0">
                 <a:solidFill>
-                  <a:srgbClr val="CFD8E6"/>
+                  <a:srgbClr val="2B374B"/>
                 </a:solidFill>
                 <a:latin typeface="Calibri"/>
               </a:rPr>
@@ -10662,7 +10686,7 @@
             <a:r>
               <a:rPr sz="1150" b="1">
                 <a:solidFill>
-                  <a:srgbClr val="5AD69C"/>
+                  <a:srgbClr val="047855"/>
                 </a:solidFill>
                 <a:latin typeface="Calibri"/>
               </a:rPr>
@@ -10671,7 +10695,7 @@
             <a:r>
               <a:rPr sz="1150" b="0">
                 <a:solidFill>
-                  <a:srgbClr val="CFD8E6"/>
+                  <a:srgbClr val="2B374B"/>
                 </a:solidFill>
                 <a:latin typeface="Calibri"/>
               </a:rPr>
@@ -10687,7 +10711,7 @@
             <a:r>
               <a:rPr sz="1150" b="1">
                 <a:solidFill>
-                  <a:srgbClr val="5AB0FF"/>
+                  <a:srgbClr val="1D4ED8"/>
                 </a:solidFill>
                 <a:latin typeface="Calibri"/>
               </a:rPr>
@@ -10696,7 +10720,7 @@
             <a:r>
               <a:rPr sz="1150" b="0">
                 <a:solidFill>
-                  <a:srgbClr val="CFD8E6"/>
+                  <a:srgbClr val="2B374B"/>
                 </a:solidFill>
                 <a:latin typeface="Calibri"/>
               </a:rPr>
@@ -10712,7 +10736,7 @@
             <a:r>
               <a:rPr sz="1100" b="1">
                 <a:solidFill>
-                  <a:srgbClr val="FFFFFF"/>
+                  <a:srgbClr val="0B1F3A"/>
                 </a:solidFill>
                 <a:latin typeface="Calibri"/>
               </a:rPr>

</xml_diff>

<commit_message>
video+deck: refresh both for the Stage-2 feature set
Video (2:38, within the 3-minute limit): re-recorded against the live app covering
all nine views. New beats: the patrol plan, the Trust Center red-team console
refusing injection and caste profiling, the audit chain verifying, a new FIR filed
in plain words joining SH-07 as case 16, the series replay crossing three
districts, the counterfactual, Person 360 and role-scoped answers.

Deck: rewritten for what the app now does, with six fresh screenshots including
the live intake and the red-team console. Benchmarks slide adds the counterfactual,
the ten-second investigation and the guardrail record. Catalyst slide separates
what is live from what is integrated with an honest status.

Also corrected a caption that hardcoded fifteen offences; the intake earlier in the
demo grows the series to sixteen.
</commit_message>
<xml_diff>
--- a/ANVESHAK_KSP_Datathon_2026_Submission.pptx
+++ b/ANVESHAK_KSP_Datathon_2026_Submission.pptx
@@ -7084,7 +7084,7 @@
                 </a:solidFill>
                 <a:latin typeface="Calibri"/>
               </a:rPr>
-              <a:t>Problem Statement:  Challenge 1 — Intelligent Conversational AI for the KSP Crime Database. Enable officers to query the FIR/crime database in natural language (English &amp; Kannada) and get accurate, evidence-grounded answers.</a:t>
+              <a:t>Problem Statement:  Challenge 1. Intelligent Conversational AI for the KSP Crime Database. Enable officers to query the FIR/crime database in natural language (English and Kannada) and get accurate, evidence-grounded answers.</a:t>
             </a:r>
           </a:p>
         </p:txBody>
@@ -7234,7 +7234,7 @@
                 </a:solidFill>
                 <a:latin typeface="Calibri"/>
               </a:rPr>
-              <a:t>• AppSail: 1 GB memory, single instance (custom Docker runtime).</a:t>
+              <a:t>• AppSail: 1 GB memory, single instance, custom Docker runtime.</a:t>
             </a:r>
           </a:p>
           <a:p>
@@ -7250,7 +7250,7 @@
                 </a:solidFill>
                 <a:latin typeface="Calibri"/>
               </a:rPr>
-              <a:t>• QuickML: GLM-4.7-Flash is a Zoho-hosted shared model — no per-model deployment cost; billed per token at production scale.</a:t>
+              <a:t>• QuickML: GLM-4.7-Flash is a Zoho-hosted shared model, so there is no per-model deployment cost; it is billed per token at production scale.</a:t>
             </a:r>
           </a:p>
           <a:p>
@@ -7266,7 +7266,7 @@
                 </a:solidFill>
                 <a:latin typeface="Calibri"/>
               </a:rPr>
-              <a:t>• Web Client Hosting + Data Store + Cron: serverless, usage-based.</a:t>
+              <a:t>• Web Client Hosting, Data Store and Cron are serverless and usage-based.</a:t>
             </a:r>
           </a:p>
           <a:p>
@@ -7282,7 +7282,7 @@
                 </a:solidFill>
                 <a:latin typeface="Calibri"/>
               </a:rPr>
-              <a:t>• Embeddings are precomputed at data-generation time, so runtime needs no GPU / heavy inference for search.</a:t>
+              <a:t>• Corpus embeddings are precomputed, and runtime embedding uses ONNX on CPU, so no GPU is required at any point.</a:t>
             </a:r>
           </a:p>
         </p:txBody>
@@ -7436,7 +7436,7 @@
                 </a:solidFill>
                 <a:latin typeface="Calibri"/>
               </a:rPr>
-              <a:t>Night Patrol — proactive leads</a:t>
+              <a:t>Night Patrol: proactive leads</a:t>
             </a:r>
           </a:p>
         </p:txBody>
@@ -7495,14 +7495,14 @@
                 </a:solidFill>
                 <a:latin typeface="Calibri"/>
               </a:rPr>
-              <a:t>Chat — answer + evidence (SQL)</a:t>
+              <a:t>Chat: answer plus its SQL evidence</a:t>
             </a:r>
           </a:p>
         </p:txBody>
       </p:sp>
       <p:pic>
         <p:nvPicPr>
-          <p:cNvPr id="119" name="Picture 118" descr="03_series.png"/>
+          <p:cNvPr id="119" name="Picture 118" descr="07_intake.png"/>
           <p:cNvPicPr>
             <a:picLocks noChangeAspect="1"/>
           </p:cNvPicPr>
@@ -7554,7 +7554,7 @@
                 </a:solidFill>
                 <a:latin typeface="Calibri"/>
               </a:rPr>
-              <a:t>Serial linkage — SH-07</a:t>
+              <a:t>New FIR joins a live series</a:t>
             </a:r>
           </a:p>
         </p:txBody>
@@ -7613,14 +7613,14 @@
                 </a:solidFill>
                 <a:latin typeface="Calibri"/>
               </a:rPr>
-              <a:t>Investigation Pack — 6 agents</a:t>
+              <a:t>Investigation Pack: six agents</a:t>
             </a:r>
           </a:p>
         </p:txBody>
       </p:sp>
       <p:pic>
         <p:nvPicPr>
-          <p:cNvPr id="123" name="Picture 122" descr="05_graph.png"/>
+          <p:cNvPr id="123" name="Picture 122" descr="08_trust.png"/>
           <p:cNvPicPr>
             <a:picLocks noChangeAspect="1"/>
           </p:cNvPicPr>
@@ -7672,14 +7672,14 @@
                 </a:solidFill>
                 <a:latin typeface="Calibri"/>
               </a:rPr>
-              <a:t>CrimeGraph — fraud hub</a:t>
+              <a:t>Trust Center: red-team console</a:t>
             </a:r>
           </a:p>
         </p:txBody>
       </p:sp>
       <p:pic>
         <p:nvPicPr>
-          <p:cNvPr id="125" name="Picture 124" descr="06_kannada.png"/>
+          <p:cNvPr id="125" name="Picture 124" descr="09_person.png"/>
           <p:cNvPicPr>
             <a:picLocks noChangeAspect="1"/>
           </p:cNvPicPr>
@@ -7731,7 +7731,7 @@
                 </a:solidFill>
                 <a:latin typeface="Calibri"/>
               </a:rPr>
-              <a:t>Bilingual — ಕನ್ನಡ + English</a:t>
+              <a:t>Person 360</a:t>
             </a:r>
           </a:p>
         </p:txBody>
@@ -7855,11 +7855,11 @@
           <a:p>
             <a:pPr>
               <a:spcAft>
-                <a:spcPts val="500"/>
-              </a:spcAft>
-            </a:pPr>
-            <a:r>
-              <a:rPr sz="1100" b="1">
+                <a:spcPts val="400"/>
+              </a:spcAft>
+            </a:pPr>
+            <a:r>
+              <a:rPr sz="1050" b="1">
                 <a:solidFill>
                   <a:srgbClr val="0B1F3A"/>
                 </a:solidFill>
@@ -7868,48 +7868,48 @@
               <a:t>Dataset:  </a:t>
             </a:r>
             <a:r>
-              <a:rPr sz="1100" b="0">
+              <a:rPr sz="1050" b="0">
                 <a:solidFill>
                   <a:srgbClr val="2B374B"/>
                 </a:solidFill>
                 <a:latin typeface="Calibri"/>
               </a:rPr>
-              <a:t>15,405 FIRs · 31 districts · 248 stations · 2023–2026 (synthetic, seed 42).</a:t>
+              <a:t>15,405 FIRs, 31 districts, 248 stations, 2023 to 2026 (synthetic, seed 42).</a:t>
             </a:r>
           </a:p>
           <a:p>
             <a:pPr>
               <a:spcAft>
-                <a:spcPts val="500"/>
-              </a:spcAft>
-            </a:pPr>
-            <a:r>
-              <a:rPr sz="1100" b="1">
+                <a:spcPts val="400"/>
+              </a:spcAft>
+            </a:pPr>
+            <a:r>
+              <a:rPr sz="1050" b="1">
                 <a:solidFill>
                   <a:srgbClr val="0B1F3A"/>
                 </a:solidFill>
                 <a:latin typeface="Calibri"/>
               </a:rPr>
-              <a:t>NL→SQL accuracy:  </a:t>
-            </a:r>
-            <a:r>
-              <a:rPr sz="1100" b="0">
+              <a:t>Natural language to SQL:  </a:t>
+            </a:r>
+            <a:r>
+              <a:rPr sz="1050" b="0">
                 <a:solidFill>
                   <a:srgbClr val="2B374B"/>
                 </a:solidFill>
                 <a:latin typeface="Calibri"/>
               </a:rPr>
-              <a:t>76.7% overall (EN 82.2%, KN 60.0%) on the local 7B dev model; gold-vs-gold 100%. Production GLM-4.7-Flash is expected higher.</a:t>
+              <a:t>76.7% overall (English 82.2%, Kannada 60.0%) measured on the local 7B development model; gold-versus-gold 100%. A live harness re-measures against the deployed GLM.</a:t>
             </a:r>
           </a:p>
           <a:p>
             <a:pPr>
               <a:spcAft>
-                <a:spcPts val="500"/>
-              </a:spcAft>
-            </a:pPr>
-            <a:r>
-              <a:rPr sz="1100" b="1">
+                <a:spcPts val="400"/>
+              </a:spcAft>
+            </a:pPr>
+            <a:r>
+              <a:rPr sz="1050" b="1">
                 <a:solidFill>
                   <a:srgbClr val="0B1F3A"/>
                 </a:solidFill>
@@ -7918,118 +7918,143 @@
               <a:t>Serial linkage (SH-07):  </a:t>
             </a:r>
             <a:r>
-              <a:rPr sz="1100" b="0">
+              <a:rPr sz="1050" b="0">
                 <a:solidFill>
                   <a:srgbClr val="2B374B"/>
                 </a:solidFill>
                 <a:latin typeface="Calibri"/>
               </a:rPr>
-              <a:t>precision 0.86 · recall 12/14; the disjoint SP-2 series correctly not merged.</a:t>
+              <a:t>precision 0.86, recall 12 of 14; the disjoint SP-2 series is correctly not merged.</a:t>
             </a:r>
           </a:p>
           <a:p>
             <a:pPr>
               <a:spcAft>
-                <a:spcPts val="500"/>
-              </a:spcAft>
-            </a:pPr>
-            <a:r>
-              <a:rPr sz="1100" b="1">
+                <a:spcPts val="400"/>
+              </a:spcAft>
+            </a:pPr>
+            <a:r>
+              <a:rPr sz="1050" b="1">
                 <a:solidFill>
                   <a:srgbClr val="0B1F3A"/>
                 </a:solidFill>
                 <a:latin typeface="Calibri"/>
               </a:rPr>
+              <a:t>Counterfactual:  </a:t>
+            </a:r>
+            <a:r>
+              <a:rPr sz="1050" b="0">
+                <a:solidFill>
+                  <a:srgbClr val="2B374B"/>
+                </a:solidFill>
+                <a:latin typeface="Calibri"/>
+              </a:rPr>
+              <a:t>the series becomes detectable at case 6; nine further offences across three districts followed over 142 days.</a:t>
+            </a:r>
+          </a:p>
+          <a:p>
+            <a:pPr>
+              <a:spcAft>
+                <a:spcPts val="400"/>
+              </a:spcAft>
+            </a:pPr>
+            <a:r>
+              <a:rPr sz="1050" b="1">
+                <a:solidFill>
+                  <a:srgbClr val="0B1F3A"/>
+                </a:solidFill>
+                <a:latin typeface="Calibri"/>
+              </a:rPr>
+              <a:t>Investigation Cell:  </a:t>
+            </a:r>
+            <a:r>
+              <a:rPr sz="1050" b="0">
+                <a:solidFill>
+                  <a:srgbClr val="2B374B"/>
+                </a:solidFill>
+                <a:latin typeface="Calibri"/>
+              </a:rPr>
+              <a:t>six agents complete in about 10 seconds, producing 8 ranked suspects.</a:t>
+            </a:r>
+          </a:p>
+          <a:p>
+            <a:pPr>
+              <a:spcAft>
+                <a:spcPts val="400"/>
+              </a:spcAft>
+            </a:pPr>
+            <a:r>
+              <a:rPr sz="1050" b="1">
+                <a:solidFill>
+                  <a:srgbClr val="0B1F3A"/>
+                </a:solidFill>
+                <a:latin typeface="Calibri"/>
+              </a:rPr>
               <a:t>Forecast (burglary):  </a:t>
             </a:r>
             <a:r>
-              <a:rPr sz="1100" b="0">
+              <a:rPr sz="1050" b="0">
                 <a:solidFill>
                   <a:srgbClr val="2B374B"/>
                 </a:solidFill>
                 <a:latin typeface="Calibri"/>
               </a:rPr>
-              <a:t>backtest MAE 1.83 vs seasonal-naive 1.75 — competitive and honestly reported.</a:t>
+              <a:t>backtest MAE 1.83 against a seasonal-naive 1.75, which is competitive and honestly reported.</a:t>
             </a:r>
           </a:p>
           <a:p>
             <a:pPr>
               <a:spcAft>
-                <a:spcPts val="500"/>
-              </a:spcAft>
-            </a:pPr>
-            <a:r>
-              <a:rPr sz="1100" b="1">
+                <a:spcPts val="400"/>
+              </a:spcAft>
+            </a:pPr>
+            <a:r>
+              <a:rPr sz="1050" b="1">
                 <a:solidFill>
                   <a:srgbClr val="0B1F3A"/>
                 </a:solidFill>
                 <a:latin typeface="Calibri"/>
               </a:rPr>
-              <a:t>Repeat-offender risk:  </a:t>
-            </a:r>
-            <a:r>
-              <a:rPr sz="1100" b="0">
+              <a:t>Guardrails:  </a:t>
+            </a:r>
+            <a:r>
+              <a:rPr sz="1050" b="0">
                 <a:solidFill>
                   <a:srgbClr val="2B374B"/>
                 </a:solidFill>
                 <a:latin typeface="Calibri"/>
               </a:rPr>
-              <a:t>Suresh B scores 0.83 (recency / frequency / gravity / centrality).</a:t>
+              <a:t>10 of 10 attack vectors blocked, re-tested live on every Trust Center load.</a:t>
             </a:r>
           </a:p>
           <a:p>
             <a:pPr>
               <a:spcAft>
-                <a:spcPts val="500"/>
-              </a:spcAft>
-            </a:pPr>
-            <a:r>
-              <a:rPr sz="1100" b="1">
+                <a:spcPts val="400"/>
+              </a:spcAft>
+            </a:pPr>
+            <a:r>
+              <a:rPr sz="1050" b="1">
                 <a:solidFill>
                   <a:srgbClr val="0B1F3A"/>
                 </a:solidFill>
                 <a:latin typeface="Calibri"/>
               </a:rPr>
-              <a:t>Night Patrol:  </a:t>
-            </a:r>
-            <a:r>
-              <a:rPr sz="1100" b="0">
+              <a:t>Robustness:  </a:t>
+            </a:r>
+            <a:r>
+              <a:rPr sz="1050" b="0">
                 <a:solidFill>
                   <a:srgbClr val="2B374B"/>
                 </a:solidFill>
                 <a:latin typeface="Calibri"/>
               </a:rPr>
-              <a:t>Whitefield spike + repeat-offender cluster fire on the planted anomalies.</a:t>
+              <a:t>thread-safe analytical layer: 60 concurrent requests, zero errors; caches pre-warmed at startup.</a:t>
             </a:r>
           </a:p>
           <a:p>
             <a:pPr>
               <a:spcAft>
-                <a:spcPts val="500"/>
-              </a:spcAft>
-            </a:pPr>
-            <a:r>
-              <a:rPr sz="1100" b="1">
-                <a:solidFill>
-                  <a:srgbClr val="0B1F3A"/>
-                </a:solidFill>
-                <a:latin typeface="Calibri"/>
-              </a:rPr>
-              <a:t>Robustness:  </a:t>
-            </a:r>
-            <a:r>
-              <a:rPr sz="1100" b="0">
-                <a:solidFill>
-                  <a:srgbClr val="2B374B"/>
-                </a:solidFill>
-                <a:latin typeface="Calibri"/>
-              </a:rPr>
-              <a:t>thread-safe analytical layer — 60 concurrent requests, 0 errors; caches pre-warmed at startup.</a:t>
-            </a:r>
-          </a:p>
-          <a:p>
-            <a:pPr>
-              <a:spcAft>
                 <a:spcPts val="200"/>
               </a:spcAft>
             </a:pPr>
@@ -8040,7 +8065,7 @@
                 </a:solidFill>
                 <a:latin typeface="Calibri"/>
               </a:rPr>
-              <a:t>Linkage ground truth is public (data_engine/planted/*.yaml) — numbers are independently verifiable.</a:t>
+              <a:t>Linkage ground truth is public (data_engine/planted/*.yaml), so these numbers are independently verifiable.</a:t>
             </a:r>
           </a:p>
         </p:txBody>
@@ -8233,7 +8258,7 @@
                 </a:solidFill>
                 <a:latin typeface="Calibri"/>
               </a:rPr>
-              <a:t>(add your public YouTube / Drive link)</a:t>
+              <a:t>(add your public YouTube or Drive link)</a:t>
             </a:r>
           </a:p>
           <a:p>
@@ -8399,7 +8424,7 @@
                 </a:solidFill>
                 <a:latin typeface="Calibri"/>
               </a:rPr>
-              <a:t>• RBAC server-side scope injection (designed, ADR-8) → full enforcement via Catalyst Auth.</a:t>
+              <a:t>• CCTNS integration: a live read connection plus identity resolution on name, parentage and date of birth, replacing the synthetic person key.</a:t>
             </a:r>
           </a:p>
           <a:p>
@@ -8415,7 +8440,7 @@
                 </a:solidFill>
                 <a:latin typeface="Calibri"/>
               </a:rPr>
-              <a:t>• Live Data Store loader + FIR-intake write-back; NoSQL graph persistence.</a:t>
+              <a:t>• Catalyst Auth issuing real officer identities into the scope layer that already enforces them server-side.</a:t>
             </a:r>
           </a:p>
           <a:p>
@@ -8431,7 +8456,7 @@
                 </a:solidFill>
                 <a:latin typeface="Calibri"/>
               </a:rPr>
-              <a:t>• SmartBrowz pack PDF, Cron schedule, and Signals / Mail digests fully wired end-to-end.</a:t>
+              <a:t>• Kannada tuning with hand-curated examples from real officer phrasing, which is our clearest measured gap.</a:t>
             </a:r>
           </a:p>
           <a:p>
@@ -8447,7 +8472,7 @@
                 </a:solidFill>
                 <a:latin typeface="Calibri"/>
               </a:rPr>
-              <a:t>• Real CCTNS identity resolution (name / parentage / DOB) replacing the synthetic person_key.</a:t>
+              <a:t>• Human-in-the-loop learning: every analyst Confirm or Reject on a series becomes a label that improves precision.</a:t>
             </a:r>
           </a:p>
           <a:p>
@@ -8463,7 +8488,7 @@
                 </a:solidFill>
                 <a:latin typeface="Calibri"/>
               </a:rPr>
-              <a:t>• Kannada NL→SQL tuning (hand-curated few-shots) to lift KN accuracy toward the EN level.</a:t>
+              <a:t>• Photo intake: scan a paper FIR with a vision model, so the workflow starts where policing actually starts.</a:t>
             </a:r>
           </a:p>
           <a:p>
@@ -8479,7 +8504,7 @@
                 </a:solidFill>
                 <a:latin typeface="Calibri"/>
               </a:rPr>
-              <a:t>• Human-in-the-loop feedback on linkage / leads to continuously improve precision.</a:t>
+              <a:t>• A pilot with one district's live data.</a:t>
             </a:r>
           </a:p>
         </p:txBody>
@@ -8770,7 +8795,7 @@
                 </a:solidFill>
                 <a:latin typeface="Calibri"/>
               </a:rPr>
-              <a:t> = “the investigator”) turns the KSP crime database into an </a:t>
+              <a:t> = "the investigator") turns the KSP crime database into an </a:t>
             </a:r>
             <a:r>
               <a:rPr sz="1300" b="1">
@@ -8788,7 +8813,7 @@
                 </a:solidFill>
                 <a:latin typeface="Calibri"/>
               </a:rPr>
-              <a:t> — not just a chatbot.</a:t>
+              <a:t>, not just a chatbot.</a:t>
             </a:r>
           </a:p>
           <a:p>
@@ -8804,7 +8829,7 @@
                 </a:solidFill>
                 <a:latin typeface="Calibri"/>
               </a:rPr>
-              <a:t>• Ask in Kannada or English, by voice or text — get an answer in seconds, </a:t>
+              <a:t>• Ask in Kannada or English, by voice or text, and get an answer in seconds </a:t>
             </a:r>
             <a:r>
               <a:rPr sz="1200" b="1">
@@ -8813,7 +8838,7 @@
                 </a:solidFill>
                 <a:latin typeface="Calibri"/>
               </a:rPr>
-              <a:t>with the evidence</a:t>
+              <a:t>with the evidence attached</a:t>
             </a:r>
             <a:r>
               <a:rPr sz="1200" b="0">
@@ -8822,7 +8847,7 @@
                 </a:solidFill>
                 <a:latin typeface="Calibri"/>
               </a:rPr>
-              <a:t> (SQL + rows + case IDs) attached. No SQL skills, no analyst queue.</a:t>
+              <a:t>: the SQL, the rows, the case IDs. No SQL skills, no analyst queue.</a:t>
             </a:r>
           </a:p>
           <a:p>
@@ -8838,7 +8863,7 @@
                 </a:solidFill>
                 <a:latin typeface="Calibri"/>
               </a:rPr>
-              <a:t>• Deterministic tools compute; the LLM only narrates</a:t>
+              <a:t>• Deterministic tools compute; the model only narrates.</a:t>
             </a:r>
             <a:r>
               <a:rPr sz="1200" b="0">
@@ -8847,7 +8872,7 @@
                 </a:solidFill>
                 <a:latin typeface="Calibri"/>
               </a:rPr>
-              <a:t> — every number traces to a tool result. Zero hallucinated statistics — essential for policing.</a:t>
+              <a:t> Every number traces to a tool result, so there are no invented statistics. That is what makes it usable in policing.</a:t>
             </a:r>
           </a:p>
           <a:p>
@@ -8863,7 +8888,7 @@
                 </a:solidFill>
                 <a:latin typeface="Calibri"/>
               </a:rPr>
-              <a:t>• It doesn’t stop at answers — it works cases: links serial crime across districts, runs a 6-agent cell that assembles court-ready packs, traverses a crime knowledge graph, and sweeps overnight to raise leads before anyone asks.</a:t>
+              <a:t>• It does not stop at answers, it works cases: links serial crime across district boundaries, files new FIRs and links them live, runs a six-agent cell that assembles court-ready packs, and sweeps overnight to raise leads before anyone asks.</a:t>
             </a:r>
           </a:p>
           <a:p>
@@ -8879,7 +8904,7 @@
                 </a:solidFill>
                 <a:latin typeface="Calibri"/>
               </a:rPr>
-              <a:t>• Impact: minutes instead of days, catches siloed records miss, and proactive leads every morning. </a:t>
+              <a:t>• Impact: minutes instead of days, catches that siloed records miss, and a ranked lead list every morning. </a:t>
             </a:r>
             <a:r>
               <a:rPr sz="1200" b="1">
@@ -9049,7 +9074,7 @@
                 </a:solidFill>
                 <a:latin typeface="Calibri"/>
               </a:rPr>
-              <a:t>• Most “crime chatbots” stop at NL→SQL. ANVESHAK adds an investigation layer: cross-district serial linkage, multi-agent case work, and proactive patrol.</a:t>
+              <a:t>• Most "crime chatbots" stop at natural language to SQL. ANVESHAK adds an investigation layer: cross-district serial linkage, live FIR intake, multi-agent case work and proactive patrol.</a:t>
             </a:r>
           </a:p>
           <a:p>
@@ -9074,7 +9099,7 @@
                 </a:solidFill>
                 <a:latin typeface="Calibri"/>
               </a:rPr>
-              <a:t>the LLM never invents numbers (deterministic tools + evidence drawer), and the linkage ground truth is public so results are independently verifiable.</a:t>
+              <a:t>the model never invents numbers, the linkage ground truth is public, role scope is enforced in the query, and the audit log is tamper-evident. There is a red-team console in the product so anyone can test it.</a:t>
             </a:r>
           </a:p>
           <a:p>
@@ -9124,7 +9149,7 @@
                 </a:solidFill>
                 <a:latin typeface="Calibri"/>
               </a:rPr>
-              <a:t>bilingual (Kannada + English) with browser voice, government-grade UI.</a:t>
+              <a:t>bilingual Kannada and English, voice or text, government-grade UI.</a:t>
             </a:r>
           </a:p>
           <a:p>
@@ -9149,7 +9174,7 @@
                 </a:solidFill>
                 <a:latin typeface="Calibri"/>
               </a:rPr>
-              <a:t>a constable at a rural station gets a statewide answer in Kannada in seconds · an SP spots a serial ring crossing Mandya into Bengaluru before the next strike · an IO gets a first-draft, court-ready pack in minutes · a control room sees tomorrow’s hotspot tonight.</a:t>
+              <a:t>a constable at a rural station gets a statewide answer in Kannada in seconds; an SP spots a ring crossing Mandya into Bengaluru before the next strike; an IO gets a first-draft court-ready pack in minutes; a control room sees tomorrow's hotspot tonight.</a:t>
             </a:r>
           </a:p>
           <a:p>
@@ -9174,7 +9199,7 @@
                 </a:solidFill>
                 <a:latin typeface="Calibri"/>
               </a:rPr>
-              <a:t>“Ask a question, get a verified answer with evidence — and let the AI work the case end-to-end to a court-ready pack.”</a:t>
+              <a:t>"Ask a question, get a verified answer with evidence, and let the AI work the case end to end to a court-ready pack."</a:t>
             </a:r>
           </a:p>
         </p:txBody>
@@ -9298,11 +9323,11 @@
           <a:p>
             <a:pPr>
               <a:spcAft>
-                <a:spcPts val="500"/>
-              </a:spcAft>
-            </a:pPr>
-            <a:r>
-              <a:rPr sz="1150" b="1">
+                <a:spcPts val="400"/>
+              </a:spcAft>
+            </a:pPr>
+            <a:r>
+              <a:rPr sz="1050" b="1">
                 <a:solidFill>
                   <a:srgbClr val="0B1F3A"/>
                 </a:solidFill>
@@ -9311,23 +9336,23 @@
               <a:t>1. Conversational floor</a:t>
             </a:r>
             <a:r>
-              <a:rPr sz="1150" b="0">
+              <a:rPr sz="1050" b="0">
                 <a:solidFill>
                   <a:srgbClr val="2B374B"/>
                 </a:solidFill>
                 <a:latin typeface="Calibri"/>
               </a:rPr>
-              <a:t> — bilingual EN + Kannada, voice + text, verified NL→SQL with evidence drawer on every answer.</a:t>
+              <a:t>: bilingual English and Kannada, voice or text, verified natural-language-to-SQL with an evidence drawer on every answer.</a:t>
             </a:r>
           </a:p>
           <a:p>
             <a:pPr>
               <a:spcAft>
-                <a:spcPts val="500"/>
-              </a:spcAft>
-            </a:pPr>
-            <a:r>
-              <a:rPr sz="1150" b="1">
+                <a:spcPts val="400"/>
+              </a:spcAft>
+            </a:pPr>
+            <a:r>
+              <a:rPr sz="1050" b="1">
                 <a:solidFill>
                   <a:srgbClr val="0B1F3A"/>
                 </a:solidFill>
@@ -9336,138 +9361,163 @@
               <a:t>2. Serial Crime Linkage Engine</a:t>
             </a:r>
             <a:r>
-              <a:rPr sz="1150" b="0">
+              <a:rPr sz="1050" b="0">
                 <a:solidFill>
                   <a:srgbClr val="2B374B"/>
                 </a:solidFill>
                 <a:latin typeface="Calibri"/>
               </a:rPr>
-              <a:t> — MO fingerprinting (multilingual embeddings + structured features), weighted cosine, HDBSCAN, 180-day / 120-km filter; discovers cross-district series cold.</a:t>
+              <a:t>: MO fingerprinting (multilingual embeddings plus structured features), weighted cosine, HDBSCAN, 180-day / 120-km filter. Discovers cross-district series cold.</a:t>
             </a:r>
           </a:p>
           <a:p>
             <a:pPr>
               <a:spcAft>
-                <a:spcPts val="500"/>
-              </a:spcAft>
-            </a:pPr>
-            <a:r>
-              <a:rPr sz="1150" b="1">
+                <a:spcPts val="400"/>
+              </a:spcAft>
+            </a:pPr>
+            <a:r>
+              <a:rPr sz="1050" b="1">
                 <a:solidFill>
                   <a:srgbClr val="0B1F3A"/>
                 </a:solidFill>
                 <a:latin typeface="Calibri"/>
               </a:rPr>
-              <a:t>3. AI Investigation Cell</a:t>
-            </a:r>
-            <a:r>
-              <a:rPr sz="1150" b="0">
+              <a:t>3. Live FIR intake</a:t>
+            </a:r>
+            <a:r>
+              <a:rPr sz="1050" b="0">
                 <a:solidFill>
                   <a:srgbClr val="2B374B"/>
                 </a:solidFill>
                 <a:latin typeface="Calibri"/>
               </a:rPr>
-              <a:t> — 6 agents stream their reasoning over SSE → court-ready Investigation Pack (PDF).</a:t>
+              <a:t>: file a new FIR in plain words, typed or dictated in Kannada. It is embedded at runtime and joins a matching series immediately.</a:t>
             </a:r>
           </a:p>
           <a:p>
             <a:pPr>
               <a:spcAft>
-                <a:spcPts val="500"/>
-              </a:spcAft>
-            </a:pPr>
-            <a:r>
-              <a:rPr sz="1150" b="1">
+                <a:spcPts val="400"/>
+              </a:spcAft>
+            </a:pPr>
+            <a:r>
+              <a:rPr sz="1050" b="1">
                 <a:solidFill>
                   <a:srgbClr val="0B1F3A"/>
                 </a:solidFill>
                 <a:latin typeface="Calibri"/>
               </a:rPr>
-              <a:t>4. CrimeGraph</a:t>
-            </a:r>
-            <a:r>
-              <a:rPr sz="1150" b="0">
+              <a:t>4. AI Investigation Cell</a:t>
+            </a:r>
+            <a:r>
+              <a:rPr sz="1050" b="0">
                 <a:solidFill>
                   <a:srgbClr val="2B374B"/>
                 </a:solidFill>
                 <a:latin typeface="Calibri"/>
               </a:rPr>
-              <a:t> — knowledge graph over people/cases; ego-network, shortest path, Louvain communities for multi-hop questions.</a:t>
+              <a:t>: six agents stream their reasoning and assemble a court-ready Investigation Pack, rendered to PDF by SmartBrowz.</a:t>
             </a:r>
           </a:p>
           <a:p>
             <a:pPr>
               <a:spcAft>
-                <a:spcPts val="500"/>
-              </a:spcAft>
-            </a:pPr>
-            <a:r>
-              <a:rPr sz="1150" b="1">
+                <a:spcPts val="400"/>
+              </a:spcAft>
+            </a:pPr>
+            <a:r>
+              <a:rPr sz="1050" b="1">
                 <a:solidFill>
                   <a:srgbClr val="0B1F3A"/>
                 </a:solidFill>
                 <a:latin typeface="Calibri"/>
               </a:rPr>
-              <a:t>5. Night Patrol</a:t>
-            </a:r>
-            <a:r>
-              <a:rPr sz="1150" b="0">
+              <a:t>5. CrimeGraph and Person 360</a:t>
+            </a:r>
+            <a:r>
+              <a:rPr sz="1050" b="0">
                 <a:solidFill>
                   <a:srgbClr val="2B374B"/>
                 </a:solidFill>
                 <a:latin typeface="Calibri"/>
               </a:rPr>
-              <a:t> — spike / series-growth / repeat-offender detectors → ranked Lead Cards, autonomously.</a:t>
+              <a:t>: a knowledge graph over people and cases, plus one page holding a person's whole footprint, risk breakdown and associates.</a:t>
             </a:r>
           </a:p>
           <a:p>
             <a:pPr>
               <a:spcAft>
-                <a:spcPts val="500"/>
-              </a:spcAft>
-            </a:pPr>
-            <a:r>
-              <a:rPr sz="1150" b="1">
+                <a:spcPts val="400"/>
+              </a:spcAft>
+            </a:pPr>
+            <a:r>
+              <a:rPr sz="1050" b="1">
                 <a:solidFill>
                   <a:srgbClr val="0B1F3A"/>
                 </a:solidFill>
                 <a:latin typeface="Calibri"/>
               </a:rPr>
-              <a:t>6. Court-ready outputs</a:t>
-            </a:r>
-            <a:r>
-              <a:rPr sz="1150" b="0">
+              <a:t>6. Night Patrol and patrol plans</a:t>
+            </a:r>
+            <a:r>
+              <a:rPr sz="1050" b="0">
                 <a:solidFill>
                   <a:srgbClr val="2B374B"/>
                 </a:solidFill>
                 <a:latin typeface="Calibri"/>
               </a:rPr>
-              <a:t> — Investigation Pack + conversation-to-PDF via SmartBrowz.</a:t>
+              <a:t>: spike, series-growth and repeat-offender detectors produce ranked lead cards, then a deployment plan per district.</a:t>
             </a:r>
           </a:p>
           <a:p>
             <a:pPr>
               <a:spcAft>
-                <a:spcPts val="500"/>
-              </a:spcAft>
-            </a:pPr>
-            <a:r>
-              <a:rPr sz="1150" b="1">
+                <a:spcPts val="400"/>
+              </a:spcAft>
+            </a:pPr>
+            <a:r>
+              <a:rPr sz="1050" b="1">
                 <a:solidFill>
                   <a:srgbClr val="0B1F3A"/>
                 </a:solidFill>
                 <a:latin typeface="Calibri"/>
               </a:rPr>
-              <a:t>7. Governance</a:t>
-            </a:r>
-            <a:r>
-              <a:rPr sz="1150" b="0">
+              <a:t>7. Trust Center</a:t>
+            </a:r>
+            <a:r>
+              <a:rPr sz="1050" b="0">
                 <a:solidFill>
                   <a:srgbClr val="2B374B"/>
                 </a:solidFill>
                 <a:latin typeface="Calibri"/>
               </a:rPr>
-              <a:t> — RBAC scopes (SHO/SP/SCRB/analyst), audit log, and no protected attributes (religion/caste) in any model (ADR-9).</a:t>
+              <a:t>: live metrics, a red-team console anyone can attack, and a hash-chained audit log that proves history has not been rewritten.</a:t>
+            </a:r>
+          </a:p>
+          <a:p>
+            <a:pPr>
+              <a:spcAft>
+                <a:spcPts val="400"/>
+              </a:spcAft>
+            </a:pPr>
+            <a:r>
+              <a:rPr sz="1050" b="1">
+                <a:solidFill>
+                  <a:srgbClr val="0B1F3A"/>
+                </a:solidFill>
+                <a:latin typeface="Calibri"/>
+              </a:rPr>
+              <a:t>8. Governance</a:t>
+            </a:r>
+            <a:r>
+              <a:rPr sz="1050" b="0">
+                <a:solidFill>
+                  <a:srgbClr val="2B374B"/>
+                </a:solidFill>
+                <a:latin typeface="Calibri"/>
+              </a:rPr>
+              <a:t>: role scope enforced server-side (SHO, SP, SCRB, analyst with masked names), and no protected attributes in any model (ADR-9).</a:t>
             </a:r>
           </a:p>
         </p:txBody>
@@ -9601,7 +9651,7 @@
                 </a:solidFill>
                 <a:latin typeface="Calibri"/>
               </a:rPr>
-              <a:t>Officer (EN/KN, voice or text)  →  React SPA  →  FastAPI intent router:</a:t>
+              <a:t>Officer (English or Kannada, voice or text) to React SPA to a FastAPI intent router:</a:t>
             </a:r>
           </a:p>
           <a:p>
@@ -9617,7 +9667,7 @@
                 </a:solidFill>
                 <a:latin typeface="Calibri"/>
               </a:rPr>
-              <a:t>• NL→SQL path: </a:t>
+              <a:t>• Question path: </a:t>
             </a:r>
             <a:r>
               <a:rPr sz="1200" b="0">
@@ -9626,7 +9676,7 @@
                 </a:solidFill>
                 <a:latin typeface="Calibri"/>
               </a:rPr>
-              <a:t>schema card + few-shots → sqlglot guardrails (SELECT-only, auto-LIMIT, self-repair) → DuckDB → answer + evidence drawer.</a:t>
+              <a:t>schema card and few-shots, then guardrails (SELECT-only, allowlisted tables, no file IO), the ADR-9 policy screen, role-scope injection, and self-repair. Answer plus evidence drawer.</a:t>
             </a:r>
           </a:p>
           <a:p>
@@ -9651,7 +9701,7 @@
                 </a:solidFill>
                 <a:latin typeface="Calibri"/>
               </a:rPr>
-              <a:t>linkage / graph / forecast / hotspots / risk / similar → DuckDB → verified result → LLM narrates.</a:t>
+              <a:t>linkage, graph, forecast, hotspots, risk and similarity tools compute on DuckDB; the model narrates the verified result.</a:t>
             </a:r>
           </a:p>
           <a:p>
@@ -9667,6 +9717,31 @@
                 </a:solidFill>
                 <a:latin typeface="Calibri"/>
               </a:rPr>
+              <a:t>• New FIR: </a:t>
+            </a:r>
+            <a:r>
+              <a:rPr sz="1200" b="0">
+                <a:solidFill>
+                  <a:srgbClr val="2B374B"/>
+                </a:solidFill>
+                <a:latin typeface="Calibri"/>
+              </a:rPr>
+              <a:t>the narrative is embedded at runtime by ONNX, written to Data Store and the mirror, linkage re-runs, and the officer is told which series it joined.</a:t>
+            </a:r>
+          </a:p>
+          <a:p>
+            <a:pPr>
+              <a:spcAft>
+                <a:spcPts val="400"/>
+              </a:spcAft>
+            </a:pPr>
+            <a:r>
+              <a:rPr sz="1200" b="1">
+                <a:solidFill>
+                  <a:srgbClr val="1D4ED8"/>
+                </a:solidFill>
+                <a:latin typeface="Calibri"/>
+              </a:rPr>
               <a:t>• Investigation: </a:t>
             </a:r>
             <a:r>
@@ -9676,7 +9751,7 @@
                 </a:solidFill>
                 <a:latin typeface="Calibri"/>
               </a:rPr>
-              <a:t>“Investigate SH-07” → 6-agent pipeline (SSE) → Investigation Pack → SmartBrowz PDF.</a:t>
+              <a:t>"Investigate SH-07" starts the six-agent pipeline over SSE, ending in the Investigation Pack and its PDF.</a:t>
             </a:r>
           </a:p>
           <a:p>
@@ -9701,7 +9776,7 @@
                 </a:solidFill>
                 <a:latin typeface="Calibri"/>
               </a:rPr>
-              <a:t>Cron → Night Patrol detectors → Lead Cards → Signals / Mail digest.</a:t>
+              <a:t>Cron runs Night Patrol, which produces lead cards, a patrol plan and a spoken Kannada morning briefing.</a:t>
             </a:r>
           </a:p>
           <a:p>
@@ -9726,7 +9801,7 @@
                 </a:solidFill>
                 <a:latin typeface="Calibri"/>
               </a:rPr>
-              <a:t>Catalyst Data Store = system of record; an embedded DuckDB analytical mirror serves sub-second analytics.</a:t>
+              <a:t>Catalyst Data Store is the system of record; an embedded DuckDB mirror serves sub-second analytics.</a:t>
             </a:r>
           </a:p>
         </p:txBody>
@@ -9860,7 +9935,7 @@
                 </a:solidFill>
                 <a:latin typeface="Calibri"/>
               </a:rPr>
-              <a:t>Six views in the live prototype (government-grade dark theme):</a:t>
+              <a:t>Nine views in the live prototype (government-grade dark theme):</a:t>
             </a:r>
           </a:p>
           <a:p>
@@ -9870,7 +9945,7 @@
               </a:spcAft>
             </a:pPr>
             <a:r>
-              <a:rPr sz="1150" b="1">
+              <a:rPr sz="1100" b="1">
                 <a:solidFill>
                   <a:srgbClr val="0B1F3A"/>
                 </a:solidFill>
@@ -9879,13 +9954,13 @@
               <a:t>• Chat</a:t>
             </a:r>
             <a:r>
-              <a:rPr sz="1150" b="0">
+              <a:rPr sz="1100" b="0">
                 <a:solidFill>
                   <a:srgbClr val="2B374B"/>
                 </a:solidFill>
                 <a:latin typeface="Calibri"/>
               </a:rPr>
-              <a:t> — bilingual answer + evidence drawer (SQL, rows, case IDs) + voice input.</a:t>
+              <a:t>: bilingual answer, evidence drawer, voice input, scope badge.</a:t>
             </a:r>
           </a:p>
           <a:p>
@@ -9895,7 +9970,7 @@
               </a:spcAft>
             </a:pPr>
             <a:r>
-              <a:rPr sz="1150" b="1">
+              <a:rPr sz="1100" b="1">
                 <a:solidFill>
                   <a:srgbClr val="0B1F3A"/>
                 </a:solidFill>
@@ -9904,13 +9979,13 @@
               <a:t>• Lead Feed</a:t>
             </a:r>
             <a:r>
-              <a:rPr sz="1150" b="0">
+              <a:rPr sz="1100" b="0">
                 <a:solidFill>
                   <a:srgbClr val="2B374B"/>
                 </a:solidFill>
                 <a:latin typeface="Calibri"/>
               </a:rPr>
-              <a:t> — ranked Night-Patrol Lead Cards.</a:t>
+              <a:t>: ranked Night-Patrol cards, patrol plan, spoken briefing.</a:t>
             </a:r>
           </a:p>
           <a:p>
@@ -9920,7 +9995,7 @@
               </a:spcAft>
             </a:pPr>
             <a:r>
-              <a:rPr sz="1150" b="1">
+              <a:rPr sz="1100" b="1">
                 <a:solidFill>
                   <a:srgbClr val="0B1F3A"/>
                 </a:solidFill>
@@ -9929,13 +10004,13 @@
               <a:t>• Series</a:t>
             </a:r>
             <a:r>
-              <a:rPr sz="1150" b="0">
+              <a:rPr sz="1100" b="0">
                 <a:solidFill>
                   <a:srgbClr val="2B374B"/>
                 </a:solidFill>
                 <a:latin typeface="Calibri"/>
               </a:rPr>
-              <a:t> — discovered serial-crime hypotheses with confidence + linked case IDs.</a:t>
+              <a:t>: discovered series with codename, link explanations, replay and the counterfactual banner.</a:t>
             </a:r>
           </a:p>
           <a:p>
@@ -9945,22 +10020,97 @@
               </a:spcAft>
             </a:pPr>
             <a:r>
-              <a:rPr sz="1150" b="1">
+              <a:rPr sz="1100" b="1">
                 <a:solidFill>
                   <a:srgbClr val="0B1F3A"/>
                 </a:solidFill>
                 <a:latin typeface="Calibri"/>
               </a:rPr>
+              <a:t>• New FIR</a:t>
+            </a:r>
+            <a:r>
+              <a:rPr sz="1100" b="0">
+                <a:solidFill>
+                  <a:srgbClr val="2B374B"/>
+                </a:solidFill>
+                <a:latin typeface="Calibri"/>
+              </a:rPr>
+              <a:t>: file a case in plain words and watch it join a series.</a:t>
+            </a:r>
+          </a:p>
+          <a:p>
+            <a:pPr>
+              <a:spcAft>
+                <a:spcPts val="400"/>
+              </a:spcAft>
+            </a:pPr>
+            <a:r>
+              <a:rPr sz="1100" b="1">
+                <a:solidFill>
+                  <a:srgbClr val="0B1F3A"/>
+                </a:solidFill>
+                <a:latin typeface="Calibri"/>
+              </a:rPr>
+              <a:t>• Investigation Room</a:t>
+            </a:r>
+            <a:r>
+              <a:rPr sz="1100" b="0">
+                <a:solidFill>
+                  <a:srgbClr val="2B374B"/>
+                </a:solidFill>
+                <a:latin typeface="Calibri"/>
+              </a:rPr>
+              <a:t>: six agents streaming, then the assembled pack.</a:t>
+            </a:r>
+          </a:p>
+          <a:p>
+            <a:pPr>
+              <a:spcAft>
+                <a:spcPts val="400"/>
+              </a:spcAft>
+            </a:pPr>
+            <a:r>
+              <a:rPr sz="1100" b="1">
+                <a:solidFill>
+                  <a:srgbClr val="0B1F3A"/>
+                </a:solidFill>
+                <a:latin typeface="Calibri"/>
+              </a:rPr>
+              <a:t>• Person 360</a:t>
+            </a:r>
+            <a:r>
+              <a:rPr sz="1100" b="0">
+                <a:solidFill>
+                  <a:srgbClr val="2B374B"/>
+                </a:solidFill>
+                <a:latin typeface="Calibri"/>
+              </a:rPr>
+              <a:t>: one person's history, risk breakdown, network, associates.</a:t>
+            </a:r>
+          </a:p>
+          <a:p>
+            <a:pPr>
+              <a:spcAft>
+                <a:spcPts val="400"/>
+              </a:spcAft>
+            </a:pPr>
+            <a:r>
+              <a:rPr sz="1100" b="1">
+                <a:solidFill>
+                  <a:srgbClr val="0B1F3A"/>
+                </a:solidFill>
+                <a:latin typeface="Calibri"/>
+              </a:rPr>
               <a:t>• CrimeGraph</a:t>
             </a:r>
             <a:r>
-              <a:rPr sz="1150" b="0">
+              <a:rPr sz="1100" b="0">
                 <a:solidFill>
                   <a:srgbClr val="2B374B"/>
                 </a:solidFill>
                 <a:latin typeface="Calibri"/>
               </a:rPr>
-              <a:t> — interactive people/case network with community highlighting.</a:t>
+              <a:t>: interactive people and case network.</a:t>
             </a:r>
           </a:p>
           <a:p>
@@ -9970,22 +10120,22 @@
               </a:spcAft>
             </a:pPr>
             <a:r>
-              <a:rPr sz="1150" b="1">
+              <a:rPr sz="1100" b="1">
                 <a:solidFill>
                   <a:srgbClr val="0B1F3A"/>
                 </a:solidFill>
                 <a:latin typeface="Calibri"/>
               </a:rPr>
-              <a:t>• Investigation Room</a:t>
-            </a:r>
-            <a:r>
-              <a:rPr sz="1150" b="0">
+              <a:t>• Trust Center</a:t>
+            </a:r>
+            <a:r>
+              <a:rPr sz="1100" b="0">
                 <a:solidFill>
                   <a:srgbClr val="2B374B"/>
                 </a:solidFill>
                 <a:latin typeface="Calibri"/>
               </a:rPr>
-              <a:t> — six agent cards stream live, then the assembled pack.</a:t>
+              <a:t>: metrics, red-team console, audit-chain verification.</a:t>
             </a:r>
           </a:p>
           <a:p>
@@ -9995,7 +10145,7 @@
               </a:spcAft>
             </a:pPr>
             <a:r>
-              <a:rPr sz="1150" b="1">
+              <a:rPr sz="1100" b="1">
                 <a:solidFill>
                   <a:srgbClr val="0B1F3A"/>
                 </a:solidFill>
@@ -10004,13 +10154,13 @@
               <a:t>• Audit</a:t>
             </a:r>
             <a:r>
-              <a:rPr sz="1150" b="0">
+              <a:rPr sz="1100" b="0">
                 <a:solidFill>
                   <a:srgbClr val="2B374B"/>
                 </a:solidFill>
                 <a:latin typeface="Calibri"/>
               </a:rPr>
-              <a:t> — every action logged (user, role, action, detail).</a:t>
+              <a:t>: every action logged with its role.</a:t>
             </a:r>
           </a:p>
           <a:p>
@@ -10020,7 +10170,7 @@
               </a:spcAft>
             </a:pPr>
             <a:r>
-              <a:rPr sz="1100" b="0">
+              <a:rPr sz="1050" b="0">
                 <a:solidFill>
                   <a:srgbClr val="1D4ED8"/>
                 </a:solidFill>
@@ -10154,13 +10304,13 @@
               </a:spcAft>
             </a:pPr>
             <a:r>
-              <a:rPr sz="1100" b="0">
+              <a:rPr sz="1050" b="0">
                 <a:solidFill>
                   <a:srgbClr val="2B374B"/>
                 </a:solidFill>
                 <a:latin typeface="Calibri"/>
               </a:rPr>
-              <a:t>Officer (EN/KN, voice+text)</a:t>
+              <a:t>Officer (English / Kannada, voice and text)</a:t>
             </a:r>
           </a:p>
           <a:p>
@@ -10170,13 +10320,13 @@
               </a:spcAft>
             </a:pPr>
             <a:r>
-              <a:rPr sz="1100" b="0">
+              <a:rPr sz="1050" b="0">
                 <a:solidFill>
                   <a:srgbClr val="2B374B"/>
                 </a:solidFill>
                 <a:latin typeface="Calibri"/>
               </a:rPr>
-              <a:t>React SPA  (served on Catalyst)</a:t>
+              <a:t>React SPA, served by the backend at /ui</a:t>
             </a:r>
           </a:p>
           <a:p>
@@ -10186,13 +10336,13 @@
               </a:spcAft>
             </a:pPr>
             <a:r>
-              <a:rPr sz="1100" b="0">
+              <a:rPr sz="1050" b="0">
                 <a:solidFill>
                   <a:srgbClr val="2B374B"/>
                 </a:solidFill>
                 <a:latin typeface="Calibri"/>
               </a:rPr>
-              <a:t>FastAPI backend on Catalyst AppSail  →  intent router</a:t>
+              <a:t>FastAPI on Catalyst AppSail, then the intent router</a:t>
             </a:r>
           </a:p>
           <a:p>
@@ -10202,13 +10352,13 @@
               </a:spcAft>
             </a:pPr>
             <a:r>
-              <a:rPr sz="1100" b="0">
+              <a:rPr sz="1050" b="0">
                 <a:solidFill>
                   <a:srgbClr val="64748B"/>
                 </a:solidFill>
                 <a:latin typeface="Calibri"/>
               </a:rPr>
-              <a:t>⤷  NL→SQL (guardrails + self-repair)   and   typed tools</a:t>
+              <a:t>guardrails, ADR-9 policy, role scope, self-repair, and typed tools</a:t>
             </a:r>
           </a:p>
           <a:p>
@@ -10218,13 +10368,13 @@
               </a:spcAft>
             </a:pPr>
             <a:r>
-              <a:rPr sz="1100" b="0">
+              <a:rPr sz="1050" b="0">
                 <a:solidFill>
                   <a:srgbClr val="64748B"/>
                 </a:solidFill>
                 <a:latin typeface="Calibri"/>
               </a:rPr>
-              <a:t>(linkage · graph · forecast · hotspots · risk · similar)</a:t>
+              <a:t>(linkage, graph, forecast, hotspots, risk, similarity)</a:t>
             </a:r>
           </a:p>
           <a:p>
@@ -10234,13 +10384,13 @@
               </a:spcAft>
             </a:pPr>
             <a:r>
-              <a:rPr sz="1100" b="0">
+              <a:rPr sz="1050" b="0">
                 <a:solidFill>
                   <a:srgbClr val="2B374B"/>
                 </a:solidFill>
                 <a:latin typeface="Calibri"/>
               </a:rPr>
-              <a:t>DuckDB analytical mirror  ⟷  Catalyst Data Store (system of record)</a:t>
+              <a:t>DuckDB analytical mirror, with Catalyst Data Store as system of record</a:t>
             </a:r>
           </a:p>
           <a:p>
@@ -10250,13 +10400,13 @@
               </a:spcAft>
             </a:pPr>
             <a:r>
-              <a:rPr sz="1100" b="0">
+              <a:rPr sz="1050" b="0">
                 <a:solidFill>
                   <a:srgbClr val="2B374B"/>
                 </a:solidFill>
                 <a:latin typeface="Calibri"/>
               </a:rPr>
-              <a:t>LLM adapter  →  Catalyst QuickML  →  GLM-4.7-Flash</a:t>
+              <a:t>ONNX MiniLM embeds new text at runtime, with no external model calls</a:t>
             </a:r>
           </a:p>
           <a:p>
@@ -10266,13 +10416,13 @@
               </a:spcAft>
             </a:pPr>
             <a:r>
-              <a:rPr sz="1100" b="0">
+              <a:rPr sz="1050" b="0">
                 <a:solidFill>
                   <a:srgbClr val="2B374B"/>
                 </a:solidFill>
                 <a:latin typeface="Calibri"/>
               </a:rPr>
-              <a:t>6-agent Investigation Cell (SSE)  →  SmartBrowz  →  Pack PDF</a:t>
+              <a:t>LLM adapter to Catalyst QuickML, serving GLM-4.7-Flash</a:t>
             </a:r>
           </a:p>
           <a:p>
@@ -10282,18 +10432,34 @@
               </a:spcAft>
             </a:pPr>
             <a:r>
-              <a:rPr sz="1100" b="0">
+              <a:rPr sz="1050" b="0">
                 <a:solidFill>
                   <a:srgbClr val="2B374B"/>
                 </a:solidFill>
                 <a:latin typeface="Calibri"/>
               </a:rPr>
-              <a:t>Cron  →  Night Patrol detectors  →  Lead Cards</a:t>
+              <a:t>Six-agent Investigation Cell over SSE, then SmartBrowz for the pack PDF</a:t>
             </a:r>
           </a:p>
           <a:p>
             <a:pPr>
               <a:spcAft>
+                <a:spcPts val="300"/>
+              </a:spcAft>
+            </a:pPr>
+            <a:r>
+              <a:rPr sz="1050" b="0">
+                <a:solidFill>
+                  <a:srgbClr val="2B374B"/>
+                </a:solidFill>
+                <a:latin typeface="Calibri"/>
+              </a:rPr>
+              <a:t>Cron drives Night Patrol, producing lead cards and the morning briefing</a:t>
+            </a:r>
+          </a:p>
+          <a:p>
+            <a:pPr>
+              <a:spcAft>
                 <a:spcPts val="200"/>
               </a:spcAft>
             </a:pPr>
@@ -10304,7 +10470,7 @@
                 </a:solidFill>
                 <a:latin typeface="Calibri"/>
               </a:rPr>
-              <a:t>Deterministic tools, LLM narrates (ADR-2). </a:t>
+              <a:t>Deterministic tools compute, the model narrates (ADR-2). </a:t>
             </a:r>
             <a:r>
               <a:rPr sz="1050" b="0">
@@ -10456,7 +10622,7 @@
                 </a:solidFill>
                 <a:latin typeface="Calibri"/>
               </a:rPr>
-              <a:t>Python 3.12, FastAPI, DuckDB, sqlglot, sentence-transformers (paraphrase-multilingual-MiniLM-L12-v2), scikit-learn / HDBSCAN, NetworkX + Louvain, statsmodels SARIMA, sse-starlette.</a:t>
+              <a:t>Python 3.12, FastAPI, DuckDB, sqlglot, ONNX Runtime with paraphrase-multilingual-MiniLM-L12-v2, scikit-learn and HDBSCAN, NetworkX with Louvain, statsmodels SARIMA, sse-starlette.</a:t>
             </a:r>
           </a:p>
           <a:p>
@@ -10481,7 +10647,7 @@
                 </a:solidFill>
                 <a:latin typeface="Calibri"/>
               </a:rPr>
-              <a:t>React 18, Vite, Tailwind CSS, ECharts (charts + network graph), Leaflet + OpenStreetMap, Web Speech API (kn-IN voice).</a:t>
+              <a:t>React 18, Vite, Tailwind CSS, ECharts for charts and the network graph, Leaflet with OpenStreetMap, Web Speech API for kn-IN voice.</a:t>
             </a:r>
           </a:p>
           <a:p>
@@ -10506,7 +10672,7 @@
                 </a:solidFill>
                 <a:latin typeface="Calibri"/>
               </a:rPr>
-              <a:t>GLM-4.7-Flash served via Catalyst QuickML LLM Serving.</a:t>
+              <a:t>GLM-4.7-Flash served through Catalyst QuickML LLM Serving.</a:t>
             </a:r>
           </a:p>
           <a:p>
@@ -10531,7 +10697,7 @@
                 </a:solidFill>
                 <a:latin typeface="Calibri"/>
               </a:rPr>
-              <a:t>Docker (custom AppSail runtime — bakes the scientific stack).</a:t>
+              <a:t>Docker custom AppSail runtime, with the scientific stack, the embedding model and the SPA bundled in the image.</a:t>
             </a:r>
           </a:p>
           <a:p>
@@ -10556,7 +10722,7 @@
                 </a:solidFill>
                 <a:latin typeface="Calibri"/>
               </a:rPr>
-              <a:t>pytest suite (46 tests), bilingual eval harness (60 questions), public linkage ground truth.</a:t>
+              <a:t>86 tests, a 60-question bilingual eval harness, public linkage ground truth, and a post-deploy verification gate.</a:t>
             </a:r>
           </a:p>
         </p:txBody>
@@ -10699,7 +10865,7 @@
                 </a:solidFill>
                 <a:latin typeface="Calibri"/>
               </a:rPr>
-              <a:t>AppSail (FastAPI, custom Docker runtime)  ·  QuickML LLM Serving (GLM-4.7-Flash)  ·  Web Client Hosting  ·  Authentication  ·  API Gateway.</a:t>
+              <a:t>AppSail (FastAPI, custom Docker runtime), QuickML LLM Serving (GLM-4.7-Flash), Web Client Hosting, Authentication, API Gateway, SmartBrowz for the Investigation Pack PDF.</a:t>
             </a:r>
           </a:p>
           <a:p>
@@ -10715,7 +10881,7 @@
                 </a:solidFill>
                 <a:latin typeface="Calibri"/>
               </a:rPr>
-              <a:t>In the architecture / provisioned:  </a:t>
+              <a:t>Integrated, with an honest status:  </a:t>
             </a:r>
             <a:r>
               <a:rPr sz="1150" b="0">
@@ -10724,7 +10890,32 @@
                 </a:solidFill>
                 <a:latin typeface="Calibri"/>
               </a:rPr>
-              <a:t>Data Store (system of record)  ·  NoSQL (graph snapshots)  ·  SmartBrowz (pack PDF)  ·  Cron (Night Patrol)  ·  Signals + Mail (lead digests)  ·  Cache  ·  Stratus (pack storage).</a:t>
+              <a:t>Data Store as the system of record. The app reports its live connection state rather than assuming it, and FIR intake writes there as well as to the analytical mirror.</a:t>
+            </a:r>
+          </a:p>
+          <a:p>
+            <a:pPr>
+              <a:spcAft>
+                <a:spcPts val="800"/>
+              </a:spcAft>
+            </a:pPr>
+            <a:r>
+              <a:rPr sz="1150" b="1">
+                <a:solidFill>
+                  <a:srgbClr val="1D4ED8"/>
+                </a:solidFill>
+                <a:latin typeface="Calibri"/>
+              </a:rPr>
+              <a:t>In the architecture:  </a:t>
+            </a:r>
+            <a:r>
+              <a:rPr sz="1150" b="0">
+                <a:solidFill>
+                  <a:srgbClr val="2B374B"/>
+                </a:solidFill>
+                <a:latin typeface="Calibri"/>
+              </a:rPr>
+              <a:t>NoSQL for graph snapshots, Cron for Night Patrol, Signals and Mail for lead digests, Cache, and Stratus for pack storage.</a:t>
             </a:r>
           </a:p>
           <a:p>

</xml_diff>

<commit_message>
feat: report the Catalyst platform from the running process, and show it
The competition mandates Catalyst and Zoho engineers judge the entry, so 'we used
Catalyst' should be inspectable rather than a line on a slide.

backend/platform_services.py reports all twelve services with what each is used
for and a conservative status: 'live' only when something about this process
proves it (AppSail by the injected listen port, QuickML by the configured backend
answering, Data Store by a real connection), 'integrated' where the code path
exists with a runtime fallback, 'configured' otherwise. Tests assert AppSail is
not claimed live off-platform and QuickML is not claimed while another backend is
in use.

Surfaced in the Trust Center as a 'Built on Zoho Catalyst' panel, in the deck as a
per-service table with the same statuses, and as a new video beat.
</commit_message>
<xml_diff>
--- a/ANVESHAK_KSP_Datathon_2026_Submission.pptx
+++ b/ANVESHAK_KSP_Datathon_2026_Submission.pptx
@@ -10846,92 +10846,348 @@
           <a:p>
             <a:pPr>
               <a:spcAft>
-                <a:spcPts val="800"/>
+                <a:spcPts val="700"/>
               </a:spcAft>
             </a:pPr>
             <a:r>
               <a:rPr sz="1150" b="1">
                 <a:solidFill>
+                  <a:srgbClr val="0B1F3A"/>
+                </a:solidFill>
+                <a:latin typeface="Calibri"/>
+              </a:rPr>
+              <a:t>Every part of ANVESHAK runs on Catalyst. The app reports its own platform status, so this is inspectable rather than asserted:</a:t>
+            </a:r>
+          </a:p>
+          <a:p>
+            <a:pPr>
+              <a:spcAft>
+                <a:spcPts val="300"/>
+              </a:spcAft>
+            </a:pPr>
+            <a:r>
+              <a:rPr sz="1000" b="1">
+                <a:solidFill>
                   <a:srgbClr val="047855"/>
                 </a:solidFill>
                 <a:latin typeface="Calibri"/>
               </a:rPr>
-              <a:t>Live now:  </a:t>
-            </a:r>
-            <a:r>
-              <a:rPr sz="1150" b="0">
+              <a:t>LIVE       </a:t>
+            </a:r>
+            <a:r>
+              <a:rPr sz="1000" b="1">
+                <a:solidFill>
+                  <a:srgbClr val="0B1F3A"/>
+                </a:solidFill>
+                <a:latin typeface="Calibri"/>
+              </a:rPr>
+              <a:t>AppSail: </a:t>
+            </a:r>
+            <a:r>
+              <a:rPr sz="1000" b="0">
                 <a:solidFill>
                   <a:srgbClr val="2B374B"/>
                 </a:solidFill>
                 <a:latin typeface="Calibri"/>
               </a:rPr>
-              <a:t>AppSail (FastAPI, custom Docker runtime), QuickML LLM Serving (GLM-4.7-Flash), Web Client Hosting, Authentication, API Gateway, SmartBrowz for the Investigation Pack PDF.</a:t>
+              <a:t>runs the FastAPI backend and serves the React app, on a custom Docker runtime carrying the scientific stack and the embedding model</a:t>
             </a:r>
           </a:p>
           <a:p>
             <a:pPr>
               <a:spcAft>
-                <a:spcPts val="800"/>
-              </a:spcAft>
-            </a:pPr>
-            <a:r>
-              <a:rPr sz="1150" b="1">
+                <a:spcPts val="300"/>
+              </a:spcAft>
+            </a:pPr>
+            <a:r>
+              <a:rPr sz="1000" b="1">
+                <a:solidFill>
+                  <a:srgbClr val="047855"/>
+                </a:solidFill>
+                <a:latin typeface="Calibri"/>
+              </a:rPr>
+              <a:t>LIVE       </a:t>
+            </a:r>
+            <a:r>
+              <a:rPr sz="1000" b="1">
+                <a:solidFill>
+                  <a:srgbClr val="0B1F3A"/>
+                </a:solidFill>
+                <a:latin typeface="Calibri"/>
+              </a:rPr>
+              <a:t>QuickML (LLM Serving): </a:t>
+            </a:r>
+            <a:r>
+              <a:rPr sz="1000" b="0">
+                <a:solidFill>
+                  <a:srgbClr val="2B374B"/>
+                </a:solidFill>
+                <a:latin typeface="Calibri"/>
+              </a:rPr>
+              <a:t>serves GLM-4.7-Flash for question understanding and narration</a:t>
+            </a:r>
+          </a:p>
+          <a:p>
+            <a:pPr>
+              <a:spcAft>
+                <a:spcPts val="300"/>
+              </a:spcAft>
+            </a:pPr>
+            <a:r>
+              <a:rPr sz="1000" b="1">
+                <a:solidFill>
+                  <a:srgbClr val="047855"/>
+                </a:solidFill>
+                <a:latin typeface="Calibri"/>
+              </a:rPr>
+              <a:t>LIVE       </a:t>
+            </a:r>
+            <a:r>
+              <a:rPr sz="1000" b="1">
+                <a:solidFill>
+                  <a:srgbClr val="0B1F3A"/>
+                </a:solidFill>
+                <a:latin typeface="Calibri"/>
+              </a:rPr>
+              <a:t>API Gateway: </a:t>
+            </a:r>
+            <a:r>
+              <a:rPr sz="1000" b="0">
+                <a:solidFill>
+                  <a:srgbClr val="2B374B"/>
+                </a:solidFill>
+                <a:latin typeface="Calibri"/>
+              </a:rPr>
+              <a:t>fronts the deployment</a:t>
+            </a:r>
+          </a:p>
+          <a:p>
+            <a:pPr>
+              <a:spcAft>
+                <a:spcPts val="300"/>
+              </a:spcAft>
+            </a:pPr>
+            <a:r>
+              <a:rPr sz="1000" b="1">
                 <a:solidFill>
                   <a:srgbClr val="1D4ED8"/>
                 </a:solidFill>
                 <a:latin typeface="Calibri"/>
               </a:rPr>
-              <a:t>Integrated, with an honest status:  </a:t>
-            </a:r>
-            <a:r>
-              <a:rPr sz="1150" b="0">
+              <a:t>INTEGRATED </a:t>
+            </a:r>
+            <a:r>
+              <a:rPr sz="1000" b="1">
+                <a:solidFill>
+                  <a:srgbClr val="0B1F3A"/>
+                </a:solidFill>
+                <a:latin typeface="Calibri"/>
+              </a:rPr>
+              <a:t>Data Store: </a:t>
+            </a:r>
+            <a:r>
+              <a:rPr sz="1000" b="0">
                 <a:solidFill>
                   <a:srgbClr val="2B374B"/>
                 </a:solidFill>
                 <a:latin typeface="Calibri"/>
               </a:rPr>
-              <a:t>Data Store as the system of record. The app reports its live connection state rather than assuming it, and FIR intake writes there as well as to the analytical mirror.</a:t>
+              <a:t>system of record for cases and new FIR intake; the analytical mirror is rebuilt from it</a:t>
             </a:r>
           </a:p>
           <a:p>
             <a:pPr>
               <a:spcAft>
-                <a:spcPts val="800"/>
-              </a:spcAft>
-            </a:pPr>
-            <a:r>
-              <a:rPr sz="1150" b="1">
+                <a:spcPts val="300"/>
+              </a:spcAft>
+            </a:pPr>
+            <a:r>
+              <a:rPr sz="1000" b="1">
                 <a:solidFill>
                   <a:srgbClr val="1D4ED8"/>
                 </a:solidFill>
                 <a:latin typeface="Calibri"/>
               </a:rPr>
-              <a:t>In the architecture:  </a:t>
-            </a:r>
-            <a:r>
-              <a:rPr sz="1150" b="0">
+              <a:t>INTEGRATED </a:t>
+            </a:r>
+            <a:r>
+              <a:rPr sz="1000" b="1">
+                <a:solidFill>
+                  <a:srgbClr val="0B1F3A"/>
+                </a:solidFill>
+                <a:latin typeface="Calibri"/>
+              </a:rPr>
+              <a:t>SmartBrowz: </a:t>
+            </a:r>
+            <a:r>
+              <a:rPr sz="1000" b="0">
                 <a:solidFill>
                   <a:srgbClr val="2B374B"/>
                 </a:solidFill>
                 <a:latin typeface="Calibri"/>
               </a:rPr>
-              <a:t>NoSQL for graph snapshots, Cron for Night Patrol, Signals and Mail for lead digests, Cache, and Stratus for pack storage.</a:t>
+              <a:t>renders the court-ready Investigation Pack to PDF</a:t>
             </a:r>
           </a:p>
           <a:p>
             <a:pPr>
               <a:spcAft>
+                <a:spcPts val="300"/>
+              </a:spcAft>
+            </a:pPr>
+            <a:r>
+              <a:rPr sz="1000" b="1">
+                <a:solidFill>
+                  <a:srgbClr val="64748B"/>
+                </a:solidFill>
+                <a:latin typeface="Calibri"/>
+              </a:rPr>
+              <a:t>CONFIGURED </a:t>
+            </a:r>
+            <a:r>
+              <a:rPr sz="1000" b="1">
+                <a:solidFill>
+                  <a:srgbClr val="0B1F3A"/>
+                </a:solidFill>
+                <a:latin typeface="Calibri"/>
+              </a:rPr>
+              <a:t>Web Client Hosting: </a:t>
+            </a:r>
+            <a:r>
+              <a:rPr sz="1000" b="0">
+                <a:solidFill>
+                  <a:srgbClr val="2B374B"/>
+                </a:solidFill>
+                <a:latin typeface="Calibri"/>
+              </a:rPr>
+              <a:t>hosts the built React bundle as a client component</a:t>
+            </a:r>
+          </a:p>
+          <a:p>
+            <a:pPr>
+              <a:spcAft>
+                <a:spcPts val="300"/>
+              </a:spcAft>
+            </a:pPr>
+            <a:r>
+              <a:rPr sz="1000" b="1">
+                <a:solidFill>
+                  <a:srgbClr val="64748B"/>
+                </a:solidFill>
+                <a:latin typeface="Calibri"/>
+              </a:rPr>
+              <a:t>CONFIGURED </a:t>
+            </a:r>
+            <a:r>
+              <a:rPr sz="1000" b="1">
+                <a:solidFill>
+                  <a:srgbClr val="0B1F3A"/>
+                </a:solidFill>
+                <a:latin typeface="Calibri"/>
+              </a:rPr>
+              <a:t>Authentication: </a:t>
+            </a:r>
+            <a:r>
+              <a:rPr sz="1000" b="0">
+                <a:solidFill>
+                  <a:srgbClr val="2B374B"/>
+                </a:solidFill>
+                <a:latin typeface="Calibri"/>
+              </a:rPr>
+              <a:t>officer identity, feeding the role scopes the app already enforces server-side</a:t>
+            </a:r>
+          </a:p>
+          <a:p>
+            <a:pPr>
+              <a:spcAft>
+                <a:spcPts val="300"/>
+              </a:spcAft>
+            </a:pPr>
+            <a:r>
+              <a:rPr sz="1000" b="1">
+                <a:solidFill>
+                  <a:srgbClr val="64748B"/>
+                </a:solidFill>
+                <a:latin typeface="Calibri"/>
+              </a:rPr>
+              <a:t>CONFIGURED </a:t>
+            </a:r>
+            <a:r>
+              <a:rPr sz="1000" b="1">
+                <a:solidFill>
+                  <a:srgbClr val="0B1F3A"/>
+                </a:solidFill>
+                <a:latin typeface="Calibri"/>
+              </a:rPr>
+              <a:t>Cron: </a:t>
+            </a:r>
+            <a:r>
+              <a:rPr sz="1000" b="0">
+                <a:solidFill>
+                  <a:srgbClr val="2B374B"/>
+                </a:solidFill>
+                <a:latin typeface="Calibri"/>
+              </a:rPr>
+              <a:t>the overnight Night Patrol sweep, and cache warming</a:t>
+            </a:r>
+          </a:p>
+          <a:p>
+            <a:pPr>
+              <a:spcAft>
+                <a:spcPts val="300"/>
+              </a:spcAft>
+            </a:pPr>
+            <a:r>
+              <a:rPr sz="1000" b="1">
+                <a:solidFill>
+                  <a:srgbClr val="64748B"/>
+                </a:solidFill>
+                <a:latin typeface="Calibri"/>
+              </a:rPr>
+              <a:t>CONFIGURED </a:t>
+            </a:r>
+            <a:r>
+              <a:rPr sz="1000" b="1">
+                <a:solidFill>
+                  <a:srgbClr val="0B1F3A"/>
+                </a:solidFill>
+                <a:latin typeface="Calibri"/>
+              </a:rPr>
+              <a:t>NoSQL · Signals · Mail · Cache · Stratus: </a:t>
+            </a:r>
+            <a:r>
+              <a:rPr sz="1000" b="0">
+                <a:solidFill>
+                  <a:srgbClr val="2B374B"/>
+                </a:solidFill>
+                <a:latin typeface="Calibri"/>
+              </a:rPr>
+              <a:t>graph snapshots, lead digests to district officers, shared state, and pack storage</a:t>
+            </a:r>
+          </a:p>
+          <a:p>
+            <a:pPr>
+              <a:spcAft>
                 <a:spcPts val="200"/>
               </a:spcAft>
             </a:pPr>
             <a:r>
-              <a:rPr sz="1100" b="1">
+              <a:rPr sz="1050" b="1">
                 <a:solidFill>
                   <a:srgbClr val="0B1F3A"/>
                 </a:solidFill>
                 <a:latin typeface="Calibri"/>
               </a:rPr>
-              <a:t>Deployment is exclusively on Zoho Catalyst, per the competition mandate.</a:t>
+              <a:t>No external inference API is ever called from the deployed app. </a:t>
+            </a:r>
+            <a:r>
+              <a:rPr sz="1050" b="0">
+                <a:solidFill>
+                  <a:srgbClr val="2B374B"/>
+                </a:solidFill>
+                <a:latin typeface="Calibri"/>
+              </a:rPr>
+              <a:t>Open the Trust Center in the live app to see this table generated from the running process.</a:t>
             </a:r>
           </a:p>
         </p:txBody>

</xml_diff>

<commit_message>
deck: add the published demo video link (youtu.be/SpmZWo9keSI)
Filled the last placeholder on the Links slide. All three submission links now
resolve: GitHub, the live Catalyst deployment, and the YouTube demo. Re-exported
the submission PDF.
</commit_message>
<xml_diff>
--- a/ANVESHAK_KSP_Datathon_2026_Submission.pptx
+++ b/ANVESHAK_KSP_Datathon_2026_Submission.pptx
@@ -8254,11 +8254,11 @@
             <a:r>
               <a:rPr sz="1300" b="0">
                 <a:solidFill>
-                  <a:srgbClr val="64748B"/>
-                </a:solidFill>
-                <a:latin typeface="Calibri"/>
-              </a:rPr>
-              <a:t>(add your public YouTube or Drive link)</a:t>
+                  <a:srgbClr val="1D4ED8"/>
+                </a:solidFill>
+                <a:latin typeface="Calibri"/>
+              </a:rPr>
+              <a:t>https://youtu.be/SpmZWo9keSI</a:t>
             </a:r>
           </a:p>
           <a:p>

</xml_diff>